<commit_message>
Add font to powerpoint
</commit_message>
<xml_diff>
--- a/Deliverables/Presentation1.pptx
+++ b/Deliverables/Presentation1.pptx
@@ -129,7 +129,7 @@
 <file path=ppt/revisionInfo.xml><?xml version="1.0" encoding="utf-8"?>
 <p1510:revInfo xmlns:a="http://schemas.openxmlformats.org/drawingml/2006/main" xmlns:r="http://schemas.openxmlformats.org/officeDocument/2006/relationships" xmlns:p1510="http://schemas.microsoft.com/office/powerpoint/2015/10/main">
   <p1510:revLst>
-    <p1510:client id="{EADFFEA0-CC63-45EF-97E4-5A80CDB68182}" v="22" dt="2026-09-15T18:05:34.469"/>
+    <p1510:client id="{EADFFEA0-CC63-45EF-97E4-5A80CDB68182}" v="24" dt="2026-09-15T18:22:47.122"/>
   </p1510:revLst>
 </p1510:revInfo>
 </file>
@@ -139,7 +139,7 @@
   <pc:docChgLst>
     <pc:chgData name="Steve Mutrux" userId="4fa98d0c-dc66-4728-b09b-a88e22e95094" providerId="ADAL" clId="{421BD283-33D8-4C6C-821F-71755E863FA2}"/>
     <pc:docChg chg="undo custSel addSld delSld modSld sldOrd">
-      <pc:chgData name="Steve Mutrux" userId="4fa98d0c-dc66-4728-b09b-a88e22e95094" providerId="ADAL" clId="{421BD283-33D8-4C6C-821F-71755E863FA2}" dt="2026-09-15T18:03:14.809" v="439" actId="20577"/>
+      <pc:chgData name="Steve Mutrux" userId="4fa98d0c-dc66-4728-b09b-a88e22e95094" providerId="ADAL" clId="{421BD283-33D8-4C6C-821F-71755E863FA2}" dt="2026-09-15T18:30:11.896" v="704" actId="20577"/>
       <pc:docMkLst>
         <pc:docMk/>
       </pc:docMkLst>
@@ -190,7 +190,7 @@
         </pc:spChg>
       </pc:sldChg>
       <pc:sldChg chg="addSp delSp modSp add mod">
-        <pc:chgData name="Steve Mutrux" userId="4fa98d0c-dc66-4728-b09b-a88e22e95094" providerId="ADAL" clId="{421BD283-33D8-4C6C-821F-71755E863FA2}" dt="2026-09-15T17:36:24.997" v="255" actId="20577"/>
+        <pc:chgData name="Steve Mutrux" userId="4fa98d0c-dc66-4728-b09b-a88e22e95094" providerId="ADAL" clId="{421BD283-33D8-4C6C-821F-71755E863FA2}" dt="2026-09-15T18:17:27.356" v="599" actId="14100"/>
         <pc:sldMkLst>
           <pc:docMk/>
           <pc:sldMk cId="518144185" sldId="258"/>
@@ -209,6 +209,14 @@
             <pc:docMk/>
             <pc:sldMk cId="518144185" sldId="258"/>
             <ac:spMk id="4" creationId="{2BF38305-4E94-805E-6DF4-E584E9A7D528}"/>
+          </ac:spMkLst>
+        </pc:spChg>
+        <pc:spChg chg="add mod">
+          <ac:chgData name="Steve Mutrux" userId="4fa98d0c-dc66-4728-b09b-a88e22e95094" providerId="ADAL" clId="{421BD283-33D8-4C6C-821F-71755E863FA2}" dt="2026-09-15T18:17:27.356" v="599" actId="14100"/>
+          <ac:spMkLst>
+            <pc:docMk/>
+            <pc:sldMk cId="518144185" sldId="258"/>
+            <ac:spMk id="4" creationId="{4179717D-B637-2B0D-B9EF-712078DD12DB}"/>
           </ac:spMkLst>
         </pc:spChg>
         <pc:spChg chg="add del">
@@ -287,7 +295,7 @@
         </pc:graphicFrameChg>
       </pc:sldChg>
       <pc:sldChg chg="addSp modSp add mod">
-        <pc:chgData name="Steve Mutrux" userId="4fa98d0c-dc66-4728-b09b-a88e22e95094" providerId="ADAL" clId="{421BD283-33D8-4C6C-821F-71755E863FA2}" dt="2026-09-15T17:56:25.658" v="313" actId="1076"/>
+        <pc:chgData name="Steve Mutrux" userId="4fa98d0c-dc66-4728-b09b-a88e22e95094" providerId="ADAL" clId="{421BD283-33D8-4C6C-821F-71755E863FA2}" dt="2026-09-15T18:30:11.896" v="704" actId="20577"/>
         <pc:sldMkLst>
           <pc:docMk/>
           <pc:sldMk cId="2553109476" sldId="265"/>
@@ -308,6 +316,14 @@
             <ac:spMk id="4" creationId="{487D995F-8AAC-6993-74EB-723E6B5C0BFF}"/>
           </ac:spMkLst>
         </pc:spChg>
+        <pc:spChg chg="add mod">
+          <ac:chgData name="Steve Mutrux" userId="4fa98d0c-dc66-4728-b09b-a88e22e95094" providerId="ADAL" clId="{421BD283-33D8-4C6C-821F-71755E863FA2}" dt="2026-09-15T18:30:11.896" v="704" actId="20577"/>
+          <ac:spMkLst>
+            <pc:docMk/>
+            <pc:sldMk cId="2553109476" sldId="265"/>
+            <ac:spMk id="5" creationId="{CC915FDB-49B9-2B7E-78DD-B03D9C91E7BB}"/>
+          </ac:spMkLst>
+        </pc:spChg>
       </pc:sldChg>
       <pc:sldChg chg="add del">
         <pc:chgData name="Steve Mutrux" userId="4fa98d0c-dc66-4728-b09b-a88e22e95094" providerId="ADAL" clId="{421BD283-33D8-4C6C-821F-71755E863FA2}" dt="2026-09-15T16:17:28.694" v="10"/>
@@ -317,7 +333,7 @@
         </pc:sldMkLst>
       </pc:sldChg>
       <pc:sldChg chg="addSp modSp add mod">
-        <pc:chgData name="Steve Mutrux" userId="4fa98d0c-dc66-4728-b09b-a88e22e95094" providerId="ADAL" clId="{421BD283-33D8-4C6C-821F-71755E863FA2}" dt="2026-09-15T17:56:28.856" v="314" actId="22"/>
+        <pc:chgData name="Steve Mutrux" userId="4fa98d0c-dc66-4728-b09b-a88e22e95094" providerId="ADAL" clId="{421BD283-33D8-4C6C-821F-71755E863FA2}" dt="2026-09-15T18:28:05.969" v="656" actId="2710"/>
         <pc:sldMkLst>
           <pc:docMk/>
           <pc:sldMk cId="353601395" sldId="266"/>
@@ -338,9 +354,17 @@
             <ac:spMk id="4" creationId="{62300D51-2B10-B557-82F3-8A6662DF3624}"/>
           </ac:spMkLst>
         </pc:spChg>
+        <pc:spChg chg="add mod">
+          <ac:chgData name="Steve Mutrux" userId="4fa98d0c-dc66-4728-b09b-a88e22e95094" providerId="ADAL" clId="{421BD283-33D8-4C6C-821F-71755E863FA2}" dt="2026-09-15T18:28:05.969" v="656" actId="2710"/>
+          <ac:spMkLst>
+            <pc:docMk/>
+            <pc:sldMk cId="353601395" sldId="266"/>
+            <ac:spMk id="5" creationId="{F48311E2-530A-88F3-A0F2-5F0110403BE1}"/>
+          </ac:spMkLst>
+        </pc:spChg>
       </pc:sldChg>
       <pc:sldChg chg="addSp modSp add mod">
-        <pc:chgData name="Steve Mutrux" userId="4fa98d0c-dc66-4728-b09b-a88e22e95094" providerId="ADAL" clId="{421BD283-33D8-4C6C-821F-71755E863FA2}" dt="2026-09-15T17:56:29.473" v="315" actId="22"/>
+        <pc:chgData name="Steve Mutrux" userId="4fa98d0c-dc66-4728-b09b-a88e22e95094" providerId="ADAL" clId="{421BD283-33D8-4C6C-821F-71755E863FA2}" dt="2026-09-15T18:28:10.064" v="657" actId="2710"/>
         <pc:sldMkLst>
           <pc:docMk/>
           <pc:sldMk cId="557364214" sldId="267"/>
@@ -361,9 +385,17 @@
             <ac:spMk id="4" creationId="{D33647DA-DFAA-FEB8-E5A2-61DBE5F52AC1}"/>
           </ac:spMkLst>
         </pc:spChg>
+        <pc:spChg chg="add mod">
+          <ac:chgData name="Steve Mutrux" userId="4fa98d0c-dc66-4728-b09b-a88e22e95094" providerId="ADAL" clId="{421BD283-33D8-4C6C-821F-71755E863FA2}" dt="2026-09-15T18:28:10.064" v="657" actId="2710"/>
+          <ac:spMkLst>
+            <pc:docMk/>
+            <pc:sldMk cId="557364214" sldId="267"/>
+            <ac:spMk id="5" creationId="{12223178-2D4D-92AC-AE08-E324647AB193}"/>
+          </ac:spMkLst>
+        </pc:spChg>
       </pc:sldChg>
       <pc:sldChg chg="addSp modSp add mod">
-        <pc:chgData name="Steve Mutrux" userId="4fa98d0c-dc66-4728-b09b-a88e22e95094" providerId="ADAL" clId="{421BD283-33D8-4C6C-821F-71755E863FA2}" dt="2026-09-15T17:56:29.987" v="316" actId="22"/>
+        <pc:chgData name="Steve Mutrux" userId="4fa98d0c-dc66-4728-b09b-a88e22e95094" providerId="ADAL" clId="{421BD283-33D8-4C6C-821F-71755E863FA2}" dt="2026-09-15T18:28:13.983" v="658" actId="2710"/>
         <pc:sldMkLst>
           <pc:docMk/>
           <pc:sldMk cId="3893094920" sldId="268"/>
@@ -376,12 +408,20 @@
             <ac:spMk id="2" creationId="{5745D002-DA86-69FC-73CA-295EFFA512FA}"/>
           </ac:spMkLst>
         </pc:spChg>
-        <pc:spChg chg="add">
-          <ac:chgData name="Steve Mutrux" userId="4fa98d0c-dc66-4728-b09b-a88e22e95094" providerId="ADAL" clId="{421BD283-33D8-4C6C-821F-71755E863FA2}" dt="2026-09-15T17:56:29.987" v="316" actId="22"/>
+        <pc:spChg chg="add mod">
+          <ac:chgData name="Steve Mutrux" userId="4fa98d0c-dc66-4728-b09b-a88e22e95094" providerId="ADAL" clId="{421BD283-33D8-4C6C-821F-71755E863FA2}" dt="2026-09-15T18:09:18.852" v="595"/>
           <ac:spMkLst>
             <pc:docMk/>
             <pc:sldMk cId="3893094920" sldId="268"/>
             <ac:spMk id="4" creationId="{417B9F22-9B70-7974-674D-300CF5BE5CE0}"/>
+          </ac:spMkLst>
+        </pc:spChg>
+        <pc:spChg chg="add mod">
+          <ac:chgData name="Steve Mutrux" userId="4fa98d0c-dc66-4728-b09b-a88e22e95094" providerId="ADAL" clId="{421BD283-33D8-4C6C-821F-71755E863FA2}" dt="2026-09-15T18:28:13.983" v="658" actId="2710"/>
+          <ac:spMkLst>
+            <pc:docMk/>
+            <pc:sldMk cId="3893094920" sldId="268"/>
+            <ac:spMk id="5" creationId="{3F61CD58-FAF9-4198-A045-50D19461C2D1}"/>
           </ac:spMkLst>
         </pc:spChg>
       </pc:sldChg>
@@ -400,14 +440,30 @@
           </ac:spMkLst>
         </pc:spChg>
       </pc:sldChg>
-      <pc:sldChg chg="addSp modSp add mod ord">
-        <pc:chgData name="Steve Mutrux" userId="4fa98d0c-dc66-4728-b09b-a88e22e95094" providerId="ADAL" clId="{421BD283-33D8-4C6C-821F-71755E863FA2}" dt="2026-09-15T18:03:14.809" v="439" actId="20577"/>
+      <pc:sldChg chg="addSp delSp modSp add mod ord">
+        <pc:chgData name="Steve Mutrux" userId="4fa98d0c-dc66-4728-b09b-a88e22e95094" providerId="ADAL" clId="{421BD283-33D8-4C6C-821F-71755E863FA2}" dt="2026-09-15T18:28:18.737" v="659" actId="2710"/>
         <pc:sldMkLst>
           <pc:docMk/>
           <pc:sldMk cId="2049535269" sldId="270"/>
         </pc:sldMkLst>
+        <pc:spChg chg="mod">
+          <ac:chgData name="Steve Mutrux" userId="4fa98d0c-dc66-4728-b09b-a88e22e95094" providerId="ADAL" clId="{421BD283-33D8-4C6C-821F-71755E863FA2}" dt="2026-09-15T18:28:18.737" v="659" actId="2710"/>
+          <ac:spMkLst>
+            <pc:docMk/>
+            <pc:sldMk cId="2049535269" sldId="270"/>
+            <ac:spMk id="2" creationId="{28A7DA79-A174-410A-3A18-3A2891D7BA9C}"/>
+          </ac:spMkLst>
+        </pc:spChg>
+        <pc:spChg chg="add del mod">
+          <ac:chgData name="Steve Mutrux" userId="4fa98d0c-dc66-4728-b09b-a88e22e95094" providerId="ADAL" clId="{421BD283-33D8-4C6C-821F-71755E863FA2}" dt="2026-09-15T18:22:48.964" v="602" actId="478"/>
+          <ac:spMkLst>
+            <pc:docMk/>
+            <pc:sldMk cId="2049535269" sldId="270"/>
+            <ac:spMk id="3" creationId="{96714B1E-886B-EC76-37F9-55D406CB28A0}"/>
+          </ac:spMkLst>
+        </pc:spChg>
         <pc:spChg chg="add mod">
-          <ac:chgData name="Steve Mutrux" userId="4fa98d0c-dc66-4728-b09b-a88e22e95094" providerId="ADAL" clId="{421BD283-33D8-4C6C-821F-71755E863FA2}" dt="2026-09-15T18:03:14.809" v="439" actId="20577"/>
+          <ac:chgData name="Steve Mutrux" userId="4fa98d0c-dc66-4728-b09b-a88e22e95094" providerId="ADAL" clId="{421BD283-33D8-4C6C-821F-71755E863FA2}" dt="2026-09-15T18:23:22.995" v="608" actId="14100"/>
           <ac:spMkLst>
             <pc:docMk/>
             <pc:sldMk cId="2049535269" sldId="270"/>
@@ -4350,6 +4406,45 @@
           </a:p>
         </p:txBody>
       </p:sp>
+      <p:sp>
+        <p:nvSpPr>
+          <p:cNvPr id="4" name="TextBox 3">
+            <a:extLst>
+              <a:ext uri="{FF2B5EF4-FFF2-40B4-BE49-F238E27FC236}">
+                <a16:creationId xmlns:a16="http://schemas.microsoft.com/office/drawing/2014/main" id="{4179717D-B637-2B0D-B9EF-712078DD12DB}"/>
+              </a:ext>
+            </a:extLst>
+          </p:cNvPr>
+          <p:cNvSpPr txBox="1"/>
+          <p:nvPr/>
+        </p:nvSpPr>
+        <p:spPr>
+          <a:xfrm>
+            <a:off x="3048680" y="3128861"/>
+            <a:ext cx="6723969" cy="3139321"/>
+          </a:xfrm>
+          <a:prstGeom prst="rect">
+            <a:avLst/>
+          </a:prstGeom>
+          <a:noFill/>
+        </p:spPr>
+        <p:txBody>
+          <a:bodyPr wrap="square">
+            <a:spAutoFit/>
+          </a:bodyPr>
+          <a:lstStyle/>
+          <a:p>
+            <a:r>
+              <a:rPr lang="en-CA" sz="1800" b="0" i="0" dirty="0">
+                <a:effectLst/>
+                <a:latin typeface="+mn-lt"/>
+              </a:rPr>
+              <a:t>Mission At Adestria, we create, develop, and implement dependable software solutions that address practical issues. We empower companies to confidently expand operations, enhance customer experience, and streamline their online presence through responsive front end design, clean architecture, and efficient back end systems. Vision To be a trustworthy technology partner with a reputation for creative software development, accessible digital design, and technical accuracy. By transforming complex requirements into accessible, and valuable user experiences, we hope to impact the direction of online and application systems in the future.</a:t>
+            </a:r>
+            <a:endParaRPr lang="en-CA" dirty="0"/>
+          </a:p>
+        </p:txBody>
+      </p:sp>
     </p:spTree>
     <p:extLst>
       <p:ext uri="{BB962C8B-B14F-4D97-AF65-F5344CB8AC3E}">
@@ -4480,6 +4575,173 @@
           </a:p>
         </p:txBody>
       </p:sp>
+      <p:sp>
+        <p:nvSpPr>
+          <p:cNvPr id="5" name="TextBox 4">
+            <a:extLst>
+              <a:ext uri="{FF2B5EF4-FFF2-40B4-BE49-F238E27FC236}">
+                <a16:creationId xmlns:a16="http://schemas.microsoft.com/office/drawing/2014/main" id="{CC915FDB-49B9-2B7E-78DD-B03D9C91E7BB}"/>
+              </a:ext>
+            </a:extLst>
+          </p:cNvPr>
+          <p:cNvSpPr txBox="1"/>
+          <p:nvPr/>
+        </p:nvSpPr>
+        <p:spPr>
+          <a:xfrm>
+            <a:off x="440111" y="376344"/>
+            <a:ext cx="1588897" cy="5997476"/>
+          </a:xfrm>
+          <a:prstGeom prst="rect">
+            <a:avLst/>
+          </a:prstGeom>
+          <a:noFill/>
+        </p:spPr>
+        <p:txBody>
+          <a:bodyPr wrap="none" rtlCol="0">
+            <a:spAutoFit/>
+          </a:bodyPr>
+          <a:lstStyle/>
+          <a:p>
+            <a:pPr>
+              <a:lnSpc>
+                <a:spcPct val="200000"/>
+              </a:lnSpc>
+            </a:pPr>
+            <a:r>
+              <a:rPr lang="en-CA" sz="2800" dirty="0">
+                <a:latin typeface="Kumbh Sans" pitchFamily="2" charset="0"/>
+                <a:cs typeface="Kumbh Sans" pitchFamily="2" charset="0"/>
+              </a:rPr>
+              <a:t>Adestria</a:t>
+            </a:r>
+          </a:p>
+          <a:p>
+            <a:pPr>
+              <a:lnSpc>
+                <a:spcPct val="200000"/>
+              </a:lnSpc>
+            </a:pPr>
+            <a:r>
+              <a:rPr lang="en-CA" sz="2800" dirty="0">
+                <a:latin typeface="Kumbh Sans" pitchFamily="2" charset="0"/>
+                <a:cs typeface="Kumbh Sans" pitchFamily="2" charset="0"/>
+              </a:rPr>
+              <a:t>    Jack</a:t>
+            </a:r>
+          </a:p>
+          <a:p>
+            <a:pPr>
+              <a:lnSpc>
+                <a:spcPct val="200000"/>
+              </a:lnSpc>
+            </a:pPr>
+            <a:r>
+              <a:rPr lang="en-CA" sz="2800" dirty="0">
+                <a:solidFill>
+                  <a:schemeClr val="tx1">
+                    <a:lumMod val="25000"/>
+                    <a:lumOff val="75000"/>
+                  </a:schemeClr>
+                </a:solidFill>
+                <a:latin typeface="Kumbh Sans" pitchFamily="2" charset="0"/>
+                <a:cs typeface="Kumbh Sans" pitchFamily="2" charset="0"/>
+              </a:rPr>
+              <a:t>    Kayla</a:t>
+            </a:r>
+          </a:p>
+          <a:p>
+            <a:pPr>
+              <a:lnSpc>
+                <a:spcPct val="200000"/>
+              </a:lnSpc>
+            </a:pPr>
+            <a:r>
+              <a:rPr lang="en-CA" sz="2800" dirty="0">
+                <a:solidFill>
+                  <a:schemeClr val="tx1">
+                    <a:lumMod val="25000"/>
+                    <a:lumOff val="75000"/>
+                  </a:schemeClr>
+                </a:solidFill>
+                <a:latin typeface="Kumbh Sans" pitchFamily="2" charset="0"/>
+                <a:cs typeface="Kumbh Sans" pitchFamily="2" charset="0"/>
+              </a:rPr>
+              <a:t>    Edin</a:t>
+            </a:r>
+          </a:p>
+          <a:p>
+            <a:pPr>
+              <a:lnSpc>
+                <a:spcPct val="200000"/>
+              </a:lnSpc>
+            </a:pPr>
+            <a:r>
+              <a:rPr lang="en-CA" sz="2800" dirty="0">
+                <a:solidFill>
+                  <a:schemeClr val="tx1">
+                    <a:lumMod val="25000"/>
+                    <a:lumOff val="75000"/>
+                  </a:schemeClr>
+                </a:solidFill>
+                <a:latin typeface="Kumbh Sans" pitchFamily="2" charset="0"/>
+                <a:cs typeface="Kumbh Sans" pitchFamily="2" charset="0"/>
+              </a:rPr>
+              <a:t>    Jake</a:t>
+            </a:r>
+          </a:p>
+          <a:p>
+            <a:pPr>
+              <a:lnSpc>
+                <a:spcPct val="200000"/>
+              </a:lnSpc>
+            </a:pPr>
+            <a:r>
+              <a:rPr lang="en-CA" sz="2800" dirty="0">
+                <a:solidFill>
+                  <a:schemeClr val="tx1">
+                    <a:lumMod val="25000"/>
+                    <a:lumOff val="75000"/>
+                  </a:schemeClr>
+                </a:solidFill>
+                <a:latin typeface="Kumbh Sans" pitchFamily="2" charset="0"/>
+                <a:cs typeface="Kumbh Sans" pitchFamily="2" charset="0"/>
+              </a:rPr>
+              <a:t>    Steve</a:t>
+            </a:r>
+          </a:p>
+          <a:p>
+            <a:pPr>
+              <a:lnSpc>
+                <a:spcPct val="200000"/>
+              </a:lnSpc>
+            </a:pPr>
+            <a:r>
+              <a:rPr lang="en-CA" sz="2800">
+                <a:solidFill>
+                  <a:schemeClr val="tx1">
+                    <a:lumMod val="25000"/>
+                    <a:lumOff val="75000"/>
+                  </a:schemeClr>
+                </a:solidFill>
+                <a:latin typeface="Kumbh Sans" pitchFamily="2" charset="0"/>
+                <a:cs typeface="Kumbh Sans" pitchFamily="2" charset="0"/>
+              </a:rPr>
+              <a:t>Project</a:t>
+            </a:r>
+            <a:endParaRPr lang="en-CA" sz="2800" dirty="0">
+              <a:solidFill>
+                <a:schemeClr val="tx1">
+                  <a:lumMod val="25000"/>
+                  <a:lumOff val="75000"/>
+                </a:schemeClr>
+              </a:solidFill>
+              <a:latin typeface="Kumbh Sans" pitchFamily="2" charset="0"/>
+              <a:cs typeface="Kumbh Sans" pitchFamily="2" charset="0"/>
+            </a:endParaRPr>
+          </a:p>
+        </p:txBody>
+      </p:sp>
     </p:spTree>
     <p:extLst>
       <p:ext uri="{BB962C8B-B14F-4D97-AF65-F5344CB8AC3E}">
@@ -4610,6 +4872,129 @@
           </a:p>
         </p:txBody>
       </p:sp>
+      <p:sp>
+        <p:nvSpPr>
+          <p:cNvPr id="5" name="TextBox 4">
+            <a:extLst>
+              <a:ext uri="{FF2B5EF4-FFF2-40B4-BE49-F238E27FC236}">
+                <a16:creationId xmlns:a16="http://schemas.microsoft.com/office/drawing/2014/main" id="{F48311E2-530A-88F3-A0F2-5F0110403BE1}"/>
+              </a:ext>
+            </a:extLst>
+          </p:cNvPr>
+          <p:cNvSpPr txBox="1"/>
+          <p:nvPr/>
+        </p:nvSpPr>
+        <p:spPr>
+          <a:xfrm>
+            <a:off x="480933" y="0"/>
+            <a:ext cx="1144865" cy="4273927"/>
+          </a:xfrm>
+          <a:prstGeom prst="rect">
+            <a:avLst/>
+          </a:prstGeom>
+          <a:noFill/>
+        </p:spPr>
+        <p:txBody>
+          <a:bodyPr wrap="none" rtlCol="0">
+            <a:spAutoFit/>
+          </a:bodyPr>
+          <a:lstStyle/>
+          <a:p>
+            <a:pPr>
+              <a:lnSpc>
+                <a:spcPct val="200000"/>
+              </a:lnSpc>
+            </a:pPr>
+            <a:r>
+              <a:rPr lang="en-CA" sz="2800" dirty="0">
+                <a:solidFill>
+                  <a:schemeClr val="tx1">
+                    <a:lumMod val="25000"/>
+                    <a:lumOff val="75000"/>
+                  </a:schemeClr>
+                </a:solidFill>
+                <a:latin typeface="Kumbh Sans" pitchFamily="2" charset="0"/>
+                <a:cs typeface="Kumbh Sans" pitchFamily="2" charset="0"/>
+              </a:rPr>
+              <a:t>Jack</a:t>
+            </a:r>
+          </a:p>
+          <a:p>
+            <a:pPr>
+              <a:lnSpc>
+                <a:spcPct val="200000"/>
+              </a:lnSpc>
+            </a:pPr>
+            <a:r>
+              <a:rPr lang="en-CA" sz="2800" dirty="0">
+                <a:latin typeface="Kumbh Sans" pitchFamily="2" charset="0"/>
+                <a:cs typeface="Kumbh Sans" pitchFamily="2" charset="0"/>
+              </a:rPr>
+              <a:t>Kayla</a:t>
+            </a:r>
+          </a:p>
+          <a:p>
+            <a:pPr>
+              <a:lnSpc>
+                <a:spcPct val="200000"/>
+              </a:lnSpc>
+            </a:pPr>
+            <a:r>
+              <a:rPr lang="en-CA" sz="2800" dirty="0">
+                <a:solidFill>
+                  <a:schemeClr val="tx1">
+                    <a:lumMod val="25000"/>
+                    <a:lumOff val="75000"/>
+                  </a:schemeClr>
+                </a:solidFill>
+                <a:latin typeface="Kumbh Sans" pitchFamily="2" charset="0"/>
+                <a:cs typeface="Kumbh Sans" pitchFamily="2" charset="0"/>
+              </a:rPr>
+              <a:t>Edin</a:t>
+            </a:r>
+          </a:p>
+          <a:p>
+            <a:pPr>
+              <a:lnSpc>
+                <a:spcPct val="200000"/>
+              </a:lnSpc>
+            </a:pPr>
+            <a:r>
+              <a:rPr lang="en-CA" sz="2800" dirty="0">
+                <a:solidFill>
+                  <a:schemeClr val="tx1">
+                    <a:lumMod val="25000"/>
+                    <a:lumOff val="75000"/>
+                  </a:schemeClr>
+                </a:solidFill>
+                <a:latin typeface="Kumbh Sans" pitchFamily="2" charset="0"/>
+                <a:cs typeface="Kumbh Sans" pitchFamily="2" charset="0"/>
+              </a:rPr>
+              <a:t>Jake</a:t>
+            </a:r>
+          </a:p>
+          <a:p>
+            <a:pPr>
+              <a:lnSpc>
+                <a:spcPct val="200000"/>
+              </a:lnSpc>
+            </a:pPr>
+            <a:r>
+              <a:rPr lang="en-CA" sz="2800" dirty="0">
+                <a:solidFill>
+                  <a:schemeClr val="tx1">
+                    <a:lumMod val="25000"/>
+                    <a:lumOff val="75000"/>
+                  </a:schemeClr>
+                </a:solidFill>
+                <a:latin typeface="Kumbh Sans" pitchFamily="2" charset="0"/>
+                <a:cs typeface="Kumbh Sans" pitchFamily="2" charset="0"/>
+              </a:rPr>
+              <a:t>Steve</a:t>
+            </a:r>
+          </a:p>
+        </p:txBody>
+      </p:sp>
     </p:spTree>
     <p:extLst>
       <p:ext uri="{BB962C8B-B14F-4D97-AF65-F5344CB8AC3E}">
@@ -4740,6 +5125,129 @@
           </a:p>
         </p:txBody>
       </p:sp>
+      <p:sp>
+        <p:nvSpPr>
+          <p:cNvPr id="5" name="TextBox 4">
+            <a:extLst>
+              <a:ext uri="{FF2B5EF4-FFF2-40B4-BE49-F238E27FC236}">
+                <a16:creationId xmlns:a16="http://schemas.microsoft.com/office/drawing/2014/main" id="{12223178-2D4D-92AC-AE08-E324647AB193}"/>
+              </a:ext>
+            </a:extLst>
+          </p:cNvPr>
+          <p:cNvSpPr txBox="1"/>
+          <p:nvPr/>
+        </p:nvSpPr>
+        <p:spPr>
+          <a:xfrm>
+            <a:off x="480933" y="0"/>
+            <a:ext cx="1144865" cy="4273927"/>
+          </a:xfrm>
+          <a:prstGeom prst="rect">
+            <a:avLst/>
+          </a:prstGeom>
+          <a:noFill/>
+        </p:spPr>
+        <p:txBody>
+          <a:bodyPr wrap="none" rtlCol="0">
+            <a:spAutoFit/>
+          </a:bodyPr>
+          <a:lstStyle/>
+          <a:p>
+            <a:pPr>
+              <a:lnSpc>
+                <a:spcPct val="200000"/>
+              </a:lnSpc>
+            </a:pPr>
+            <a:r>
+              <a:rPr lang="en-CA" sz="2800" dirty="0">
+                <a:solidFill>
+                  <a:schemeClr val="tx1">
+                    <a:lumMod val="25000"/>
+                    <a:lumOff val="75000"/>
+                  </a:schemeClr>
+                </a:solidFill>
+                <a:latin typeface="Kumbh Sans" pitchFamily="2" charset="0"/>
+                <a:cs typeface="Kumbh Sans" pitchFamily="2" charset="0"/>
+              </a:rPr>
+              <a:t>Jack</a:t>
+            </a:r>
+          </a:p>
+          <a:p>
+            <a:pPr>
+              <a:lnSpc>
+                <a:spcPct val="200000"/>
+              </a:lnSpc>
+            </a:pPr>
+            <a:r>
+              <a:rPr lang="en-CA" sz="2800" dirty="0">
+                <a:solidFill>
+                  <a:schemeClr val="tx1">
+                    <a:lumMod val="25000"/>
+                    <a:lumOff val="75000"/>
+                  </a:schemeClr>
+                </a:solidFill>
+                <a:latin typeface="Kumbh Sans" pitchFamily="2" charset="0"/>
+                <a:cs typeface="Kumbh Sans" pitchFamily="2" charset="0"/>
+              </a:rPr>
+              <a:t>Kayla</a:t>
+            </a:r>
+          </a:p>
+          <a:p>
+            <a:pPr>
+              <a:lnSpc>
+                <a:spcPct val="200000"/>
+              </a:lnSpc>
+            </a:pPr>
+            <a:r>
+              <a:rPr lang="en-CA" sz="2800" dirty="0">
+                <a:latin typeface="Kumbh Sans" pitchFamily="2" charset="0"/>
+                <a:cs typeface="Kumbh Sans" pitchFamily="2" charset="0"/>
+              </a:rPr>
+              <a:t>Edin</a:t>
+            </a:r>
+          </a:p>
+          <a:p>
+            <a:pPr>
+              <a:lnSpc>
+                <a:spcPct val="200000"/>
+              </a:lnSpc>
+            </a:pPr>
+            <a:r>
+              <a:rPr lang="en-CA" sz="2800" dirty="0">
+                <a:solidFill>
+                  <a:schemeClr val="tx1">
+                    <a:lumMod val="25000"/>
+                    <a:lumOff val="75000"/>
+                  </a:schemeClr>
+                </a:solidFill>
+                <a:latin typeface="Kumbh Sans" pitchFamily="2" charset="0"/>
+                <a:cs typeface="Kumbh Sans" pitchFamily="2" charset="0"/>
+              </a:rPr>
+              <a:t>Jake</a:t>
+            </a:r>
+          </a:p>
+          <a:p>
+            <a:pPr>
+              <a:lnSpc>
+                <a:spcPct val="200000"/>
+              </a:lnSpc>
+            </a:pPr>
+            <a:r>
+              <a:rPr lang="en-CA" sz="2800" dirty="0">
+                <a:solidFill>
+                  <a:schemeClr val="tx1">
+                    <a:lumMod val="25000"/>
+                    <a:lumOff val="75000"/>
+                  </a:schemeClr>
+                </a:solidFill>
+                <a:latin typeface="Kumbh Sans" pitchFamily="2" charset="0"/>
+                <a:cs typeface="Kumbh Sans" pitchFamily="2" charset="0"/>
+              </a:rPr>
+              <a:t>Steve</a:t>
+            </a:r>
+          </a:p>
+        </p:txBody>
+      </p:sp>
     </p:spTree>
     <p:extLst>
       <p:ext uri="{BB962C8B-B14F-4D97-AF65-F5344CB8AC3E}">
@@ -4826,7 +5334,7 @@
         <p:spPr>
           <a:xfrm>
             <a:off x="4407954" y="3267475"/>
-            <a:ext cx="2050818" cy="923330"/>
+            <a:ext cx="3404137" cy="923330"/>
           </a:xfrm>
           <a:prstGeom prst="rect">
             <a:avLst/>
@@ -4865,7 +5373,130 @@
             </a:pPr>
             <a:r>
               <a:rPr lang="en-CA" dirty="0"/>
-              <a:t>Expectations</a:t>
+              <a:t>Expectations to get out of this</a:t>
+            </a:r>
+          </a:p>
+        </p:txBody>
+      </p:sp>
+      <p:sp>
+        <p:nvSpPr>
+          <p:cNvPr id="5" name="TextBox 4">
+            <a:extLst>
+              <a:ext uri="{FF2B5EF4-FFF2-40B4-BE49-F238E27FC236}">
+                <a16:creationId xmlns:a16="http://schemas.microsoft.com/office/drawing/2014/main" id="{3F61CD58-FAF9-4198-A045-50D19461C2D1}"/>
+              </a:ext>
+            </a:extLst>
+          </p:cNvPr>
+          <p:cNvSpPr txBox="1"/>
+          <p:nvPr/>
+        </p:nvSpPr>
+        <p:spPr>
+          <a:xfrm>
+            <a:off x="480933" y="0"/>
+            <a:ext cx="1144865" cy="4273927"/>
+          </a:xfrm>
+          <a:prstGeom prst="rect">
+            <a:avLst/>
+          </a:prstGeom>
+          <a:noFill/>
+        </p:spPr>
+        <p:txBody>
+          <a:bodyPr wrap="none" rtlCol="0">
+            <a:spAutoFit/>
+          </a:bodyPr>
+          <a:lstStyle/>
+          <a:p>
+            <a:pPr>
+              <a:lnSpc>
+                <a:spcPct val="200000"/>
+              </a:lnSpc>
+            </a:pPr>
+            <a:r>
+              <a:rPr lang="en-CA" sz="2800" dirty="0">
+                <a:solidFill>
+                  <a:schemeClr val="tx1">
+                    <a:lumMod val="25000"/>
+                    <a:lumOff val="75000"/>
+                  </a:schemeClr>
+                </a:solidFill>
+                <a:latin typeface="Kumbh Sans" pitchFamily="2" charset="0"/>
+                <a:cs typeface="Kumbh Sans" pitchFamily="2" charset="0"/>
+              </a:rPr>
+              <a:t>Jack</a:t>
+            </a:r>
+          </a:p>
+          <a:p>
+            <a:pPr>
+              <a:lnSpc>
+                <a:spcPct val="200000"/>
+              </a:lnSpc>
+            </a:pPr>
+            <a:r>
+              <a:rPr lang="en-CA" sz="2800" dirty="0">
+                <a:solidFill>
+                  <a:schemeClr val="tx1">
+                    <a:lumMod val="25000"/>
+                    <a:lumOff val="75000"/>
+                  </a:schemeClr>
+                </a:solidFill>
+                <a:latin typeface="Kumbh Sans" pitchFamily="2" charset="0"/>
+                <a:cs typeface="Kumbh Sans" pitchFamily="2" charset="0"/>
+              </a:rPr>
+              <a:t>Kayla</a:t>
+            </a:r>
+          </a:p>
+          <a:p>
+            <a:pPr>
+              <a:lnSpc>
+                <a:spcPct val="200000"/>
+              </a:lnSpc>
+            </a:pPr>
+            <a:r>
+              <a:rPr lang="en-CA" sz="2800" dirty="0">
+                <a:solidFill>
+                  <a:schemeClr val="tx1">
+                    <a:lumMod val="25000"/>
+                    <a:lumOff val="75000"/>
+                  </a:schemeClr>
+                </a:solidFill>
+                <a:latin typeface="Kumbh Sans" pitchFamily="2" charset="0"/>
+                <a:cs typeface="Kumbh Sans" pitchFamily="2" charset="0"/>
+              </a:rPr>
+              <a:t>Edin</a:t>
+            </a:r>
+          </a:p>
+          <a:p>
+            <a:pPr>
+              <a:lnSpc>
+                <a:spcPct val="200000"/>
+              </a:lnSpc>
+            </a:pPr>
+            <a:r>
+              <a:rPr lang="en-CA" sz="2800" dirty="0">
+                <a:latin typeface="Kumbh Sans" pitchFamily="2" charset="0"/>
+                <a:cs typeface="Kumbh Sans" pitchFamily="2" charset="0"/>
+              </a:rPr>
+              <a:t>Jake</a:t>
+            </a:r>
+          </a:p>
+          <a:p>
+            <a:pPr>
+              <a:lnSpc>
+                <a:spcPct val="200000"/>
+              </a:lnSpc>
+            </a:pPr>
+            <a:r>
+              <a:rPr lang="en-CA" sz="2800" dirty="0">
+                <a:solidFill>
+                  <a:schemeClr val="tx1">
+                    <a:lumMod val="25000"/>
+                    <a:lumOff val="75000"/>
+                  </a:schemeClr>
+                </a:solidFill>
+                <a:latin typeface="Kumbh Sans" pitchFamily="2" charset="0"/>
+                <a:cs typeface="Kumbh Sans" pitchFamily="2" charset="0"/>
+              </a:rPr>
+              <a:t>Steve</a:t>
             </a:r>
           </a:p>
         </p:txBody>
@@ -4920,8 +5551,8 @@
         </p:nvSpPr>
         <p:spPr>
           <a:xfrm>
-            <a:off x="4506686" y="2759529"/>
-            <a:ext cx="734047" cy="369332"/>
+            <a:off x="480933" y="0"/>
+            <a:ext cx="1144865" cy="4273927"/>
           </a:xfrm>
           <a:prstGeom prst="rect">
             <a:avLst/>
@@ -4934,8 +5565,96 @@
           </a:bodyPr>
           <a:lstStyle/>
           <a:p>
-            <a:r>
-              <a:rPr lang="en-CA" dirty="0"/>
+            <a:pPr>
+              <a:lnSpc>
+                <a:spcPct val="200000"/>
+              </a:lnSpc>
+            </a:pPr>
+            <a:r>
+              <a:rPr lang="en-CA" sz="2800" dirty="0">
+                <a:solidFill>
+                  <a:schemeClr val="tx1">
+                    <a:lumMod val="25000"/>
+                    <a:lumOff val="75000"/>
+                  </a:schemeClr>
+                </a:solidFill>
+                <a:latin typeface="Kumbh Sans" pitchFamily="2" charset="0"/>
+                <a:cs typeface="Kumbh Sans" pitchFamily="2" charset="0"/>
+              </a:rPr>
+              <a:t>Jack</a:t>
+            </a:r>
+          </a:p>
+          <a:p>
+            <a:pPr>
+              <a:lnSpc>
+                <a:spcPct val="200000"/>
+              </a:lnSpc>
+            </a:pPr>
+            <a:r>
+              <a:rPr lang="en-CA" sz="2800" dirty="0">
+                <a:solidFill>
+                  <a:schemeClr val="tx1">
+                    <a:lumMod val="25000"/>
+                    <a:lumOff val="75000"/>
+                  </a:schemeClr>
+                </a:solidFill>
+                <a:latin typeface="Kumbh Sans" pitchFamily="2" charset="0"/>
+                <a:cs typeface="Kumbh Sans" pitchFamily="2" charset="0"/>
+              </a:rPr>
+              <a:t>Kayla</a:t>
+            </a:r>
+          </a:p>
+          <a:p>
+            <a:pPr>
+              <a:lnSpc>
+                <a:spcPct val="200000"/>
+              </a:lnSpc>
+            </a:pPr>
+            <a:r>
+              <a:rPr lang="en-CA" sz="2800" dirty="0">
+                <a:solidFill>
+                  <a:schemeClr val="tx1">
+                    <a:lumMod val="25000"/>
+                    <a:lumOff val="75000"/>
+                  </a:schemeClr>
+                </a:solidFill>
+                <a:latin typeface="Kumbh Sans" pitchFamily="2" charset="0"/>
+                <a:cs typeface="Kumbh Sans" pitchFamily="2" charset="0"/>
+              </a:rPr>
+              <a:t>Edin</a:t>
+            </a:r>
+          </a:p>
+          <a:p>
+            <a:pPr>
+              <a:lnSpc>
+                <a:spcPct val="200000"/>
+              </a:lnSpc>
+            </a:pPr>
+            <a:r>
+              <a:rPr lang="en-CA" sz="2800" dirty="0">
+                <a:solidFill>
+                  <a:schemeClr val="tx1">
+                    <a:lumMod val="25000"/>
+                    <a:lumOff val="75000"/>
+                  </a:schemeClr>
+                </a:solidFill>
+                <a:latin typeface="Kumbh Sans" pitchFamily="2" charset="0"/>
+                <a:cs typeface="Kumbh Sans" pitchFamily="2" charset="0"/>
+              </a:rPr>
+              <a:t>Jake</a:t>
+            </a:r>
+          </a:p>
+          <a:p>
+            <a:pPr>
+              <a:lnSpc>
+                <a:spcPct val="200000"/>
+              </a:lnSpc>
+            </a:pPr>
+            <a:r>
+              <a:rPr lang="en-CA" sz="2800" dirty="0">
+                <a:latin typeface="Kumbh Sans" pitchFamily="2" charset="0"/>
+                <a:cs typeface="Kumbh Sans" pitchFamily="2" charset="0"/>
+              </a:rPr>
               <a:t>Steve</a:t>
             </a:r>
           </a:p>
@@ -4955,8 +5674,8 @@
         </p:nvSpPr>
         <p:spPr>
           <a:xfrm>
-            <a:off x="4407954" y="3267475"/>
-            <a:ext cx="9100376" cy="923330"/>
+            <a:off x="4163786" y="3429000"/>
+            <a:ext cx="7705357" cy="1200329"/>
           </a:xfrm>
           <a:prstGeom prst="rect">
             <a:avLst/>
@@ -4964,7 +5683,7 @@
           <a:noFill/>
         </p:spPr>
         <p:txBody>
-          <a:bodyPr wrap="none" rtlCol="0">
+          <a:bodyPr wrap="square" rtlCol="0">
             <a:spAutoFit/>
           </a:bodyPr>
           <a:lstStyle/>
@@ -4974,8 +5693,11 @@
               <a:buChar char="-"/>
             </a:pPr>
             <a:r>
-              <a:rPr lang="en-CA" dirty="0"/>
-              <a:t>Studied at Brock University, 3 years web dev experience, 1 year embedded firmware dev</a:t>
+              <a:rPr lang="en-CA" dirty="0">
+                <a:latin typeface="Kumbh Sans" pitchFamily="2" charset="0"/>
+                <a:cs typeface="Kumbh Sans" pitchFamily="2" charset="0"/>
+              </a:rPr>
+              <a:t>Studied Comp Sci at Brock University, 3 years web dev experience, 1 year embedded firmware dev</a:t>
             </a:r>
           </a:p>
           <a:p>
@@ -4984,8 +5706,11 @@
               <a:buChar char="-"/>
             </a:pPr>
             <a:r>
-              <a:rPr lang="en-CA" dirty="0"/>
-              <a:t>Role</a:t>
+              <a:rPr lang="en-CA" dirty="0">
+                <a:latin typeface="Kumbh Sans" pitchFamily="2" charset="0"/>
+                <a:cs typeface="Kumbh Sans" pitchFamily="2" charset="0"/>
+              </a:rPr>
+              <a:t>Admin person, making ppt, compiling doc package, …</a:t>
             </a:r>
           </a:p>
           <a:p>
@@ -4994,8 +5719,11 @@
               <a:buChar char="-"/>
             </a:pPr>
             <a:r>
-              <a:rPr lang="en-CA" dirty="0"/>
-              <a:t>Expectations to get out of this</a:t>
+              <a:rPr lang="en-CA" dirty="0">
+                <a:latin typeface="Kumbh Sans" pitchFamily="2" charset="0"/>
+                <a:cs typeface="Kumbh Sans" pitchFamily="2" charset="0"/>
+              </a:rPr>
+              <a:t>Learning to let other take the wheel and grow in their own domain</a:t>
             </a:r>
           </a:p>
         </p:txBody>

</xml_diff>

<commit_message>
Completed powerpoint with existing info
</commit_message>
<xml_diff>
--- a/Deliverables/Presentation1.pptx
+++ b/Deliverables/Presentation1.pptx
@@ -5,7 +5,7 @@
     <p:sldMasterId id="2147483648" r:id="rId1"/>
   </p:sldMasterIdLst>
   <p:notesMasterIdLst>
-    <p:notesMasterId r:id="rId19"/>
+    <p:notesMasterId r:id="rId18"/>
   </p:notesMasterIdLst>
   <p:sldIdLst>
     <p:sldId id="256" r:id="rId2"/>
@@ -24,14 +24,17 @@
     <p:sldId id="262" r:id="rId15"/>
     <p:sldId id="269" r:id="rId16"/>
     <p:sldId id="263" r:id="rId17"/>
-    <p:sldId id="271" r:id="rId18"/>
   </p:sldIdLst>
   <p:sldSz cx="12192000" cy="6858000"/>
   <p:notesSz cx="6858000" cy="9144000"/>
   <p:embeddedFontLst>
     <p:embeddedFont>
       <p:font typeface="Kumbh Sans" pitchFamily="2" charset="0"/>
-      <p:regular r:id="rId20"/>
+      <p:regular r:id="rId19"/>
+      <p:bold r:id="rId20"/>
+    </p:embeddedFont>
+    <p:embeddedFont>
+      <p:font typeface="Kumbh Sans SemiBold" pitchFamily="2" charset="0"/>
       <p:bold r:id="rId21"/>
     </p:embeddedFont>
   </p:embeddedFontLst>
@@ -142,7 +145,7 @@
 <p1510:revInfo xmlns:a="http://schemas.openxmlformats.org/drawingml/2006/main" xmlns:r="http://schemas.openxmlformats.org/officeDocument/2006/relationships" xmlns:p1510="http://schemas.microsoft.com/office/powerpoint/2015/10/main">
   <p1510:revLst>
     <p1510:client id="{2940A192-0FD3-4679-B782-39515230B446}" v="272" dt="2026-09-16T18:38:35.183"/>
-    <p1510:client id="{EADFFEA0-CC63-45EF-97E4-5A80CDB68182}" v="1745" dt="2026-09-17T17:57:23.057"/>
+    <p1510:client id="{EADFFEA0-CC63-45EF-97E4-5A80CDB68182}" v="1807" dt="2026-09-17T18:32:20.419"/>
   </p1510:revLst>
 </p1510:revInfo>
 </file>
@@ -152,7 +155,7 @@
   <pc:docChgLst>
     <pc:chgData name="Steve Mutrux" userId="4fa98d0c-dc66-4728-b09b-a88e22e95094" providerId="ADAL" clId="{421BD283-33D8-4C6C-821F-71755E863FA2}"/>
     <pc:docChg chg="undo custSel addSld delSld modSld sldOrd">
-      <pc:chgData name="Steve Mutrux" userId="4fa98d0c-dc66-4728-b09b-a88e22e95094" providerId="ADAL" clId="{421BD283-33D8-4C6C-821F-71755E863FA2}" dt="2026-09-17T17:59:39.962" v="5183" actId="1076"/>
+      <pc:chgData name="Steve Mutrux" userId="4fa98d0c-dc66-4728-b09b-a88e22e95094" providerId="ADAL" clId="{421BD283-33D8-4C6C-821F-71755E863FA2}" dt="2026-09-17T18:32:43.712" v="5292" actId="1036"/>
       <pc:docMkLst>
         <pc:docMk/>
       </pc:docMkLst>
@@ -482,7 +485,7 @@
         </pc:grpChg>
       </pc:sldChg>
       <pc:sldChg chg="addSp delSp modSp add mod ord modTransition modAnim">
-        <pc:chgData name="Steve Mutrux" userId="4fa98d0c-dc66-4728-b09b-a88e22e95094" providerId="ADAL" clId="{421BD283-33D8-4C6C-821F-71755E863FA2}" dt="2026-09-16T15:22:15.053" v="4690"/>
+        <pc:chgData name="Steve Mutrux" userId="4fa98d0c-dc66-4728-b09b-a88e22e95094" providerId="ADAL" clId="{421BD283-33D8-4C6C-821F-71755E863FA2}" dt="2026-09-17T18:05:10.212" v="5205" actId="20577"/>
         <pc:sldMkLst>
           <pc:docMk/>
           <pc:sldMk cId="3444687766" sldId="260"/>
@@ -504,7 +507,7 @@
           </ac:spMkLst>
         </pc:spChg>
         <pc:spChg chg="add mod">
-          <ac:chgData name="Steve Mutrux" userId="4fa98d0c-dc66-4728-b09b-a88e22e95094" providerId="ADAL" clId="{421BD283-33D8-4C6C-821F-71755E863FA2}" dt="2026-09-16T15:16:53.093" v="4684" actId="20577"/>
+          <ac:chgData name="Steve Mutrux" userId="4fa98d0c-dc66-4728-b09b-a88e22e95094" providerId="ADAL" clId="{421BD283-33D8-4C6C-821F-71755E863FA2}" dt="2026-09-17T18:05:10.212" v="5205" actId="20577"/>
           <ac:spMkLst>
             <pc:docMk/>
             <pc:sldMk cId="3444687766" sldId="260"/>
@@ -673,7 +676,7 @@
         </pc:grpChg>
       </pc:sldChg>
       <pc:sldChg chg="addSp delSp modSp add mod modTransition addAnim delAnim modAnim modNotesTx">
-        <pc:chgData name="Steve Mutrux" userId="4fa98d0c-dc66-4728-b09b-a88e22e95094" providerId="ADAL" clId="{421BD283-33D8-4C6C-821F-71755E863FA2}" dt="2026-09-17T17:29:59.649" v="4771" actId="20577"/>
+        <pc:chgData name="Steve Mutrux" userId="4fa98d0c-dc66-4728-b09b-a88e22e95094" providerId="ADAL" clId="{421BD283-33D8-4C6C-821F-71755E863FA2}" dt="2026-09-17T18:23:01.889" v="5235"/>
         <pc:sldMkLst>
           <pc:docMk/>
           <pc:sldMk cId="4190029259" sldId="261"/>
@@ -764,6 +767,14 @@
             <pc:docMk/>
             <pc:sldMk cId="4190029259" sldId="261"/>
             <ac:spMk id="13" creationId="{D215D108-DE09-DD98-B693-86573D2B5F59}"/>
+          </ac:spMkLst>
+        </pc:spChg>
+        <pc:spChg chg="add mod">
+          <ac:chgData name="Steve Mutrux" userId="4fa98d0c-dc66-4728-b09b-a88e22e95094" providerId="ADAL" clId="{421BD283-33D8-4C6C-821F-71755E863FA2}" dt="2026-09-17T18:21:50.529" v="5231" actId="1036"/>
+          <ac:spMkLst>
+            <pc:docMk/>
+            <pc:sldMk cId="4190029259" sldId="261"/>
+            <ac:spMk id="15" creationId="{371B18D3-D66D-246F-ADDA-BEA5981F37AE}"/>
           </ac:spMkLst>
         </pc:spChg>
         <pc:spChg chg="add del mod">
@@ -950,15 +961,23 @@
             <ac:grpSpMk id="39" creationId="{7C9560F7-8264-7EF2-E259-3151A7DA378D}"/>
           </ac:grpSpMkLst>
         </pc:grpChg>
+        <pc:picChg chg="add mod">
+          <ac:chgData name="Steve Mutrux" userId="4fa98d0c-dc66-4728-b09b-a88e22e95094" providerId="ADAL" clId="{421BD283-33D8-4C6C-821F-71755E863FA2}" dt="2026-09-17T18:21:02.149" v="5220" actId="1076"/>
+          <ac:picMkLst>
+            <pc:docMk/>
+            <pc:sldMk cId="4190029259" sldId="261"/>
+            <ac:picMk id="14" creationId="{387C92B2-EE40-6CBB-BD04-2055150745E3}"/>
+          </ac:picMkLst>
+        </pc:picChg>
       </pc:sldChg>
       <pc:sldChg chg="addSp delSp modSp add mod modTransition modAnim">
-        <pc:chgData name="Steve Mutrux" userId="4fa98d0c-dc66-4728-b09b-a88e22e95094" providerId="ADAL" clId="{421BD283-33D8-4C6C-821F-71755E863FA2}" dt="2026-09-17T17:59:39.962" v="5183" actId="1076"/>
+        <pc:chgData name="Steve Mutrux" userId="4fa98d0c-dc66-4728-b09b-a88e22e95094" providerId="ADAL" clId="{421BD283-33D8-4C6C-821F-71755E863FA2}" dt="2026-09-17T18:31:50.337" v="5283"/>
         <pc:sldMkLst>
           <pc:docMk/>
           <pc:sldMk cId="1179066660" sldId="262"/>
         </pc:sldMkLst>
-        <pc:spChg chg="add mod">
-          <ac:chgData name="Steve Mutrux" userId="4fa98d0c-dc66-4728-b09b-a88e22e95094" providerId="ADAL" clId="{421BD283-33D8-4C6C-821F-71755E863FA2}" dt="2026-09-16T12:54:11.577" v="4060" actId="207"/>
+        <pc:spChg chg="add mod ord">
+          <ac:chgData name="Steve Mutrux" userId="4fa98d0c-dc66-4728-b09b-a88e22e95094" providerId="ADAL" clId="{421BD283-33D8-4C6C-821F-71755E863FA2}" dt="2026-09-17T18:26:25.637" v="5251" actId="167"/>
           <ac:spMkLst>
             <pc:docMk/>
             <pc:sldMk cId="1179066660" sldId="262"/>
@@ -981,8 +1000,8 @@
             <ac:spMk id="4" creationId="{454DAE8C-0239-F0A4-BA7E-4FE0FF2D9897}"/>
           </ac:spMkLst>
         </pc:spChg>
-        <pc:spChg chg="mod">
-          <ac:chgData name="Steve Mutrux" userId="4fa98d0c-dc66-4728-b09b-a88e22e95094" providerId="ADAL" clId="{421BD283-33D8-4C6C-821F-71755E863FA2}" dt="2026-09-16T12:53:48.110" v="4054"/>
+        <pc:spChg chg="mod ord">
+          <ac:chgData name="Steve Mutrux" userId="4fa98d0c-dc66-4728-b09b-a88e22e95094" providerId="ADAL" clId="{421BD283-33D8-4C6C-821F-71755E863FA2}" dt="2026-09-17T18:26:33.719" v="5252" actId="167"/>
           <ac:spMkLst>
             <pc:docMk/>
             <pc:sldMk cId="1179066660" sldId="262"/>
@@ -995,6 +1014,14 @@
             <pc:docMk/>
             <pc:sldMk cId="1179066660" sldId="262"/>
             <ac:spMk id="6" creationId="{0CDADB92-84C5-A652-539F-1C8F5047D3A6}"/>
+          </ac:spMkLst>
+        </pc:spChg>
+        <pc:spChg chg="mod ord">
+          <ac:chgData name="Steve Mutrux" userId="4fa98d0c-dc66-4728-b09b-a88e22e95094" providerId="ADAL" clId="{421BD283-33D8-4C6C-821F-71755E863FA2}" dt="2026-09-17T18:27:11.032" v="5258" actId="167"/>
+          <ac:spMkLst>
+            <pc:docMk/>
+            <pc:sldMk cId="1179066660" sldId="262"/>
+            <ac:spMk id="6" creationId="{AEB2168F-CCF1-991D-5D41-6794E45BDF72}"/>
           </ac:spMkLst>
         </pc:spChg>
         <pc:spChg chg="mod">
@@ -1037,8 +1064,8 @@
             <ac:spMk id="13" creationId="{DEF5A2AF-EC07-834B-96C9-F52BF5B58A31}"/>
           </ac:spMkLst>
         </pc:spChg>
-        <pc:spChg chg="add mod">
-          <ac:chgData name="Steve Mutrux" userId="4fa98d0c-dc66-4728-b09b-a88e22e95094" providerId="ADAL" clId="{421BD283-33D8-4C6C-821F-71755E863FA2}" dt="2026-09-17T17:48:36.118" v="5108" actId="14100"/>
+        <pc:spChg chg="add del mod">
+          <ac:chgData name="Steve Mutrux" userId="4fa98d0c-dc66-4728-b09b-a88e22e95094" providerId="ADAL" clId="{421BD283-33D8-4C6C-821F-71755E863FA2}" dt="2026-09-17T18:00:06.611" v="5187" actId="1076"/>
           <ac:spMkLst>
             <pc:docMk/>
             <pc:sldMk cId="1179066660" sldId="262"/>
@@ -1126,7 +1153,7 @@
           </ac:spMkLst>
         </pc:spChg>
         <pc:grpChg chg="add mod ord">
-          <ac:chgData name="Steve Mutrux" userId="4fa98d0c-dc66-4728-b09b-a88e22e95094" providerId="ADAL" clId="{421BD283-33D8-4C6C-821F-71755E863FA2}" dt="2026-09-16T12:55:19.955" v="4069" actId="1036"/>
+          <ac:chgData name="Steve Mutrux" userId="4fa98d0c-dc66-4728-b09b-a88e22e95094" providerId="ADAL" clId="{421BD283-33D8-4C6C-821F-71755E863FA2}" dt="2026-09-17T18:26:47.148" v="5255" actId="167"/>
           <ac:grpSpMkLst>
             <pc:docMk/>
             <pc:sldMk cId="1179066660" sldId="262"/>
@@ -1182,7 +1209,7 @@
           </ac:grpSpMkLst>
         </pc:grpChg>
         <pc:graphicFrameChg chg="add mod modGraphic">
-          <ac:chgData name="Steve Mutrux" userId="4fa98d0c-dc66-4728-b09b-a88e22e95094" providerId="ADAL" clId="{421BD283-33D8-4C6C-821F-71755E863FA2}" dt="2026-09-17T17:56:49.185" v="5167" actId="20577"/>
+          <ac:chgData name="Steve Mutrux" userId="4fa98d0c-dc66-4728-b09b-a88e22e95094" providerId="ADAL" clId="{421BD283-33D8-4C6C-821F-71755E863FA2}" dt="2026-09-17T18:06:30.506" v="5209" actId="2711"/>
           <ac:graphicFrameMkLst>
             <pc:docMk/>
             <pc:sldMk cId="1179066660" sldId="262"/>
@@ -1190,8 +1217,8 @@
           </ac:graphicFrameMkLst>
         </pc:graphicFrameChg>
       </pc:sldChg>
-      <pc:sldChg chg="addSp delSp modSp add mod">
-        <pc:chgData name="Steve Mutrux" userId="4fa98d0c-dc66-4728-b09b-a88e22e95094" providerId="ADAL" clId="{421BD283-33D8-4C6C-821F-71755E863FA2}" dt="2026-09-16T00:46:05.458" v="912" actId="207"/>
+      <pc:sldChg chg="addSp delSp modSp add mod modTransition">
+        <pc:chgData name="Steve Mutrux" userId="4fa98d0c-dc66-4728-b09b-a88e22e95094" providerId="ADAL" clId="{421BD283-33D8-4C6C-821F-71755E863FA2}" dt="2026-09-17T18:12:08.424" v="5212"/>
         <pc:sldMkLst>
           <pc:docMk/>
           <pc:sldMk cId="2229155277" sldId="263"/>
@@ -1212,8 +1239,8 @@
             <ac:spMk id="4" creationId="{202A19DB-42DD-70EE-502D-F38B63917B61}"/>
           </ac:spMkLst>
         </pc:spChg>
-        <pc:spChg chg="add mod">
-          <ac:chgData name="Steve Mutrux" userId="4fa98d0c-dc66-4728-b09b-a88e22e95094" providerId="ADAL" clId="{421BD283-33D8-4C6C-821F-71755E863FA2}" dt="2026-09-16T00:46:05.458" v="912" actId="207"/>
+        <pc:spChg chg="add del mod">
+          <ac:chgData name="Steve Mutrux" userId="4fa98d0c-dc66-4728-b09b-a88e22e95094" providerId="ADAL" clId="{421BD283-33D8-4C6C-821F-71755E863FA2}" dt="2026-09-17T18:12:02.580" v="5210" actId="478"/>
           <ac:spMkLst>
             <pc:docMk/>
             <pc:sldMk cId="2229155277" sldId="263"/>
@@ -1308,8 +1335,8 @@
           </ac:spMkLst>
         </pc:spChg>
       </pc:sldChg>
-      <pc:sldChg chg="addSp delSp modSp add mod modAnim modNotesTx">
-        <pc:chgData name="Steve Mutrux" userId="4fa98d0c-dc66-4728-b09b-a88e22e95094" providerId="ADAL" clId="{421BD283-33D8-4C6C-821F-71755E863FA2}" dt="2026-09-16T11:20:21.614" v="3204" actId="1035"/>
+      <pc:sldChg chg="addSp delSp modSp add mod modTransition modAnim modNotesTx">
+        <pc:chgData name="Steve Mutrux" userId="4fa98d0c-dc66-4728-b09b-a88e22e95094" providerId="ADAL" clId="{421BD283-33D8-4C6C-821F-71755E863FA2}" dt="2026-09-17T18:13:03.669" v="5215"/>
         <pc:sldMkLst>
           <pc:docMk/>
           <pc:sldMk cId="353601395" sldId="266"/>
@@ -1427,8 +1454,8 @@
           </ac:grpSpMkLst>
         </pc:grpChg>
       </pc:sldChg>
-      <pc:sldChg chg="addSp delSp modSp add mod modAnim modNotesTx">
-        <pc:chgData name="Steve Mutrux" userId="4fa98d0c-dc66-4728-b09b-a88e22e95094" providerId="ADAL" clId="{421BD283-33D8-4C6C-821F-71755E863FA2}" dt="2026-09-16T11:20:54.556" v="3206" actId="1035"/>
+      <pc:sldChg chg="addSp delSp modSp add mod modTransition modAnim modNotesTx">
+        <pc:chgData name="Steve Mutrux" userId="4fa98d0c-dc66-4728-b09b-a88e22e95094" providerId="ADAL" clId="{421BD283-33D8-4C6C-821F-71755E863FA2}" dt="2026-09-17T18:13:06.438" v="5216"/>
         <pc:sldMkLst>
           <pc:docMk/>
           <pc:sldMk cId="557364214" sldId="267"/>
@@ -1538,8 +1565,8 @@
           </ac:grpSpMkLst>
         </pc:grpChg>
       </pc:sldChg>
-      <pc:sldChg chg="addSp delSp modSp add mod modAnim modNotesTx">
-        <pc:chgData name="Steve Mutrux" userId="4fa98d0c-dc66-4728-b09b-a88e22e95094" providerId="ADAL" clId="{421BD283-33D8-4C6C-821F-71755E863FA2}" dt="2026-09-16T11:54:25.710" v="3455" actId="1076"/>
+      <pc:sldChg chg="addSp delSp modSp add mod modTransition modAnim modNotesTx">
+        <pc:chgData name="Steve Mutrux" userId="4fa98d0c-dc66-4728-b09b-a88e22e95094" providerId="ADAL" clId="{421BD283-33D8-4C6C-821F-71755E863FA2}" dt="2026-09-17T18:13:08.592" v="5217"/>
         <pc:sldMkLst>
           <pc:docMk/>
           <pc:sldMk cId="3893094920" sldId="268"/>
@@ -1682,7 +1709,7 @@
         </pc:picChg>
       </pc:sldChg>
       <pc:sldChg chg="addSp delSp modSp add mod modAnim">
-        <pc:chgData name="Steve Mutrux" userId="4fa98d0c-dc66-4728-b09b-a88e22e95094" providerId="ADAL" clId="{421BD283-33D8-4C6C-821F-71755E863FA2}" dt="2026-09-16T13:08:23.999" v="4176" actId="1036"/>
+        <pc:chgData name="Steve Mutrux" userId="4fa98d0c-dc66-4728-b09b-a88e22e95094" providerId="ADAL" clId="{421BD283-33D8-4C6C-821F-71755E863FA2}" dt="2026-09-17T18:32:43.712" v="5292" actId="1036"/>
         <pc:sldMkLst>
           <pc:docMk/>
           <pc:sldMk cId="1755182162" sldId="269"/>
@@ -1725,6 +1752,14 @@
             <pc:docMk/>
             <pc:sldMk cId="1755182162" sldId="269"/>
             <ac:spMk id="6" creationId="{DE0AABFC-72E2-9D06-FC3C-5D2C8EFA51D3}"/>
+          </ac:spMkLst>
+        </pc:spChg>
+        <pc:spChg chg="mod">
+          <ac:chgData name="Steve Mutrux" userId="4fa98d0c-dc66-4728-b09b-a88e22e95094" providerId="ADAL" clId="{421BD283-33D8-4C6C-821F-71755E863FA2}" dt="2026-09-17T18:32:43.712" v="5292" actId="1036"/>
+          <ac:spMkLst>
+            <pc:docMk/>
+            <pc:sldMk cId="1755182162" sldId="269"/>
+            <ac:spMk id="8" creationId="{920A0F4F-D15B-3088-F2A1-AD48A979E786}"/>
           </ac:spMkLst>
         </pc:spChg>
         <pc:spChg chg="add del mod">
@@ -1831,8 +1866,8 @@
           </ac:spMkLst>
         </pc:spChg>
       </pc:sldChg>
-      <pc:sldChg chg="delSp modSp add mod">
-        <pc:chgData name="Steve Mutrux" userId="4fa98d0c-dc66-4728-b09b-a88e22e95094" providerId="ADAL" clId="{421BD283-33D8-4C6C-821F-71755E863FA2}" dt="2026-09-16T00:43:04.454" v="870" actId="478"/>
+      <pc:sldChg chg="delSp modSp add del mod">
+        <pc:chgData name="Steve Mutrux" userId="4fa98d0c-dc66-4728-b09b-a88e22e95094" providerId="ADAL" clId="{421BD283-33D8-4C6C-821F-71755E863FA2}" dt="2026-09-17T18:12:04.346" v="5211" actId="47"/>
         <pc:sldMkLst>
           <pc:docMk/>
           <pc:sldMk cId="1557603729" sldId="271"/>
@@ -1989,8 +2024,8 @@
           </ac:grpSpMkLst>
         </pc:grpChg>
       </pc:sldChg>
-      <pc:sldChg chg="addSp modSp add mod modAnim modNotesTx">
-        <pc:chgData name="Steve Mutrux" userId="4fa98d0c-dc66-4728-b09b-a88e22e95094" providerId="ADAL" clId="{421BD283-33D8-4C6C-821F-71755E863FA2}" dt="2026-09-16T11:19:32.067" v="3202" actId="1035"/>
+      <pc:sldChg chg="addSp modSp add mod modTransition modAnim modNotesTx">
+        <pc:chgData name="Steve Mutrux" userId="4fa98d0c-dc66-4728-b09b-a88e22e95094" providerId="ADAL" clId="{421BD283-33D8-4C6C-821F-71755E863FA2}" dt="2026-09-17T18:13:01.302" v="5214"/>
         <pc:sldMkLst>
           <pc:docMk/>
           <pc:sldMk cId="3925825761" sldId="273"/>
@@ -2069,7 +2104,7 @@
         </pc:grpChg>
       </pc:sldChg>
       <pc:sldChg chg="addSp delSp modSp add mod delAnim modAnim modNotesTx">
-        <pc:chgData name="Steve Mutrux" userId="4fa98d0c-dc66-4728-b09b-a88e22e95094" providerId="ADAL" clId="{421BD283-33D8-4C6C-821F-71755E863FA2}" dt="2026-09-17T17:29:17.683" v="4770" actId="20577"/>
+        <pc:chgData name="Steve Mutrux" userId="4fa98d0c-dc66-4728-b09b-a88e22e95094" providerId="ADAL" clId="{421BD283-33D8-4C6C-821F-71755E863FA2}" dt="2026-09-17T18:12:57.173" v="5213"/>
         <pc:sldMkLst>
           <pc:docMk/>
           <pc:sldMk cId="859702855" sldId="274"/>
@@ -10463,7 +10498,7 @@
                 <a:latin typeface="Kumbh Sans" pitchFamily="2" charset="0"/>
                 <a:cs typeface="Kumbh Sans" pitchFamily="2" charset="0"/>
               </a:rPr>
-              <a:t>$1,440</a:t>
+              <a:t>$1,728</a:t>
             </a:r>
           </a:p>
         </p:txBody>
@@ -15495,6 +15530,85 @@
           </a:p>
         </p:txBody>
       </p:sp>
+      <p:pic>
+        <p:nvPicPr>
+          <p:cNvPr id="14" name="Picture 13">
+            <a:extLst>
+              <a:ext uri="{FF2B5EF4-FFF2-40B4-BE49-F238E27FC236}">
+                <a16:creationId xmlns:a16="http://schemas.microsoft.com/office/drawing/2014/main" id="{387C92B2-EE40-6CBB-BD04-2055150745E3}"/>
+              </a:ext>
+            </a:extLst>
+          </p:cNvPr>
+          <p:cNvPicPr>
+            <a:picLocks noChangeAspect="1"/>
+          </p:cNvPicPr>
+          <p:nvPr/>
+        </p:nvPicPr>
+        <p:blipFill>
+          <a:blip r:embed="rId3">
+            <a:extLst>
+              <a:ext uri="{28A0092B-C50C-407E-A947-70E740481C1C}">
+                <a14:useLocalDpi xmlns:a14="http://schemas.microsoft.com/office/drawing/2010/main" val="0"/>
+              </a:ext>
+            </a:extLst>
+          </a:blip>
+          <a:stretch>
+            <a:fillRect/>
+          </a:stretch>
+        </p:blipFill>
+        <p:spPr>
+          <a:xfrm>
+            <a:off x="3402800" y="1771869"/>
+            <a:ext cx="7967662" cy="3206425"/>
+          </a:xfrm>
+          <a:prstGeom prst="rect">
+            <a:avLst/>
+          </a:prstGeom>
+        </p:spPr>
+      </p:pic>
+      <p:sp>
+        <p:nvSpPr>
+          <p:cNvPr id="15" name="TextBox 14">
+            <a:extLst>
+              <a:ext uri="{FF2B5EF4-FFF2-40B4-BE49-F238E27FC236}">
+                <a16:creationId xmlns:a16="http://schemas.microsoft.com/office/drawing/2014/main" id="{371B18D3-D66D-246F-ADDA-BEA5981F37AE}"/>
+              </a:ext>
+            </a:extLst>
+          </p:cNvPr>
+          <p:cNvSpPr txBox="1"/>
+          <p:nvPr/>
+        </p:nvSpPr>
+        <p:spPr>
+          <a:xfrm>
+            <a:off x="6178865" y="868422"/>
+            <a:ext cx="2209259" cy="721929"/>
+          </a:xfrm>
+          <a:prstGeom prst="rect">
+            <a:avLst/>
+          </a:prstGeom>
+          <a:noFill/>
+        </p:spPr>
+        <p:txBody>
+          <a:bodyPr wrap="none" rtlCol="0">
+            <a:spAutoFit/>
+          </a:bodyPr>
+          <a:lstStyle/>
+          <a:p>
+            <a:pPr algn="ctr">
+              <a:lnSpc>
+                <a:spcPct val="200000"/>
+              </a:lnSpc>
+            </a:pPr>
+            <a:r>
+              <a:rPr lang="en-CA" sz="2400" dirty="0">
+                <a:latin typeface="Kumbh Sans" pitchFamily="2" charset="0"/>
+                <a:cs typeface="Kumbh Sans" pitchFamily="2" charset="0"/>
+              </a:rPr>
+              <a:t>NCR Manager</a:t>
+            </a:r>
+          </a:p>
+        </p:txBody>
+      </p:sp>
     </p:spTree>
     <p:extLst>
       <p:ext uri="{BB962C8B-B14F-4D97-AF65-F5344CB8AC3E}">
@@ -15808,14 +15922,84 @@
                                 </p:cTn>
                               </p:par>
                               <p:par>
-                                <p:cTn id="22" presetID="1" presetClass="entr" presetSubtype="0" fill="hold" grpId="0" nodeType="withEffect">
+                                <p:cTn id="22" presetID="10" presetClass="exit" presetSubtype="0" fill="hold" nodeType="withEffect">
+                                  <p:stCondLst>
+                                    <p:cond delay="0"/>
+                                  </p:stCondLst>
+                                  <p:childTnLst>
+                                    <p:animEffect transition="out" filter="fade">
+                                      <p:cBhvr>
+                                        <p:cTn id="23" dur="500"/>
+                                        <p:tgtEl>
+                                          <p:spTgt spid="14"/>
+                                        </p:tgtEl>
+                                      </p:cBhvr>
+                                    </p:animEffect>
+                                    <p:set>
+                                      <p:cBhvr>
+                                        <p:cTn id="24" dur="1" fill="hold">
+                                          <p:stCondLst>
+                                            <p:cond delay="499"/>
+                                          </p:stCondLst>
+                                        </p:cTn>
+                                        <p:tgtEl>
+                                          <p:spTgt spid="14"/>
+                                        </p:tgtEl>
+                                        <p:attrNameLst>
+                                          <p:attrName>style.visibility</p:attrName>
+                                        </p:attrNameLst>
+                                      </p:cBhvr>
+                                      <p:to>
+                                        <p:strVal val="hidden"/>
+                                      </p:to>
+                                    </p:set>
+                                  </p:childTnLst>
+                                </p:cTn>
+                              </p:par>
+                              <p:par>
+                                <p:cTn id="25" presetID="10" presetClass="exit" presetSubtype="0" fill="hold" grpId="0" nodeType="withEffect">
+                                  <p:stCondLst>
+                                    <p:cond delay="0"/>
+                                  </p:stCondLst>
+                                  <p:childTnLst>
+                                    <p:animEffect transition="out" filter="fade">
+                                      <p:cBhvr>
+                                        <p:cTn id="26" dur="500"/>
+                                        <p:tgtEl>
+                                          <p:spTgt spid="15"/>
+                                        </p:tgtEl>
+                                      </p:cBhvr>
+                                    </p:animEffect>
+                                    <p:set>
+                                      <p:cBhvr>
+                                        <p:cTn id="27" dur="1" fill="hold">
+                                          <p:stCondLst>
+                                            <p:cond delay="499"/>
+                                          </p:stCondLst>
+                                        </p:cTn>
+                                        <p:tgtEl>
+                                          <p:spTgt spid="15"/>
+                                        </p:tgtEl>
+                                        <p:attrNameLst>
+                                          <p:attrName>style.visibility</p:attrName>
+                                        </p:attrNameLst>
+                                      </p:cBhvr>
+                                      <p:to>
+                                        <p:strVal val="hidden"/>
+                                      </p:to>
+                                    </p:set>
+                                  </p:childTnLst>
+                                </p:cTn>
+                              </p:par>
+                              <p:par>
+                                <p:cTn id="28" presetID="1" presetClass="entr" presetSubtype="0" fill="hold" grpId="0" nodeType="withEffect">
                                   <p:stCondLst>
                                     <p:cond delay="0"/>
                                   </p:stCondLst>
                                   <p:childTnLst>
                                     <p:set>
                                       <p:cBhvr>
-                                        <p:cTn id="23" dur="1" fill="hold">
+                                        <p:cTn id="29" dur="1" fill="hold">
                                           <p:stCondLst>
                                             <p:cond delay="0"/>
                                           </p:stCondLst>
@@ -15835,14 +16019,14 @@
                                 </p:cTn>
                               </p:par>
                               <p:par>
-                                <p:cTn id="24" presetID="1" presetClass="entr" presetSubtype="0" fill="hold" grpId="0" nodeType="withEffect">
+                                <p:cTn id="30" presetID="1" presetClass="entr" presetSubtype="0" fill="hold" grpId="0" nodeType="withEffect">
                                   <p:stCondLst>
                                     <p:cond delay="0"/>
                                   </p:stCondLst>
                                   <p:childTnLst>
                                     <p:set>
                                       <p:cBhvr>
-                                        <p:cTn id="25" dur="1" fill="hold">
+                                        <p:cTn id="31" dur="1" fill="hold">
                                           <p:stCondLst>
                                             <p:cond delay="0"/>
                                           </p:stCondLst>
@@ -15862,14 +16046,14 @@
                                 </p:cTn>
                               </p:par>
                               <p:par>
-                                <p:cTn id="26" presetID="1" presetClass="entr" presetSubtype="0" fill="hold" nodeType="withEffect">
+                                <p:cTn id="32" presetID="1" presetClass="entr" presetSubtype="0" fill="hold" nodeType="withEffect">
                                   <p:stCondLst>
                                     <p:cond delay="0"/>
                                   </p:stCondLst>
                                   <p:childTnLst>
                                     <p:set>
                                       <p:cBhvr>
-                                        <p:cTn id="27" dur="1" fill="hold">
+                                        <p:cTn id="33" dur="1" fill="hold">
                                           <p:stCondLst>
                                             <p:cond delay="0"/>
                                           </p:stCondLst>
@@ -15889,14 +16073,14 @@
                                 </p:cTn>
                               </p:par>
                               <p:par>
-                                <p:cTn id="28" presetID="1" presetClass="entr" presetSubtype="0" fill="hold" nodeType="withEffect">
+                                <p:cTn id="34" presetID="1" presetClass="entr" presetSubtype="0" fill="hold" nodeType="withEffect">
                                   <p:stCondLst>
                                     <p:cond delay="0"/>
                                   </p:stCondLst>
                                   <p:childTnLst>
                                     <p:set>
                                       <p:cBhvr>
-                                        <p:cTn id="29" dur="1" fill="hold">
+                                        <p:cTn id="35" dur="1" fill="hold">
                                           <p:stCondLst>
                                             <p:cond delay="0"/>
                                           </p:stCondLst>
@@ -15916,14 +16100,14 @@
                                 </p:cTn>
                               </p:par>
                               <p:par>
-                                <p:cTn id="30" presetID="42" presetClass="path" presetSubtype="0" accel="50000" decel="50000" fill="hold" grpId="1" nodeType="withEffect">
+                                <p:cTn id="36" presetID="42" presetClass="path" presetSubtype="0" accel="50000" decel="50000" fill="hold" grpId="1" nodeType="withEffect">
                                   <p:stCondLst>
                                     <p:cond delay="0"/>
                                   </p:stCondLst>
                                   <p:childTnLst>
                                     <p:animMotion origin="layout" path="M -2.29167E-6 1.11022E-16 L -2.29167E-6 0.10278 " pathEditMode="relative" rAng="0" ptsTypes="AA">
                                       <p:cBhvr>
-                                        <p:cTn id="31" dur="2000" fill="hold"/>
+                                        <p:cTn id="37" dur="2000" fill="hold"/>
                                         <p:tgtEl>
                                           <p:spTgt spid="25"/>
                                         </p:tgtEl>
@@ -15938,14 +16122,14 @@
                                 </p:cTn>
                               </p:par>
                               <p:par>
-                                <p:cTn id="32" presetID="42" presetClass="path" presetSubtype="0" accel="50000" decel="50000" fill="hold" grpId="1" nodeType="withEffect">
+                                <p:cTn id="38" presetID="42" presetClass="path" presetSubtype="0" accel="50000" decel="50000" fill="hold" grpId="1" nodeType="withEffect">
                                   <p:stCondLst>
                                     <p:cond delay="0"/>
                                   </p:stCondLst>
                                   <p:childTnLst>
                                     <p:animMotion origin="layout" path="M -2.29167E-6 3.7037E-6 L -2.29167E-6 0.18726 " pathEditMode="relative" rAng="0" ptsTypes="AA">
                                       <p:cBhvr>
-                                        <p:cTn id="33" dur="2000" fill="hold"/>
+                                        <p:cTn id="39" dur="2000" fill="hold"/>
                                         <p:tgtEl>
                                           <p:spTgt spid="23"/>
                                         </p:tgtEl>
@@ -15960,14 +16144,14 @@
                                 </p:cTn>
                               </p:par>
                               <p:par>
-                                <p:cTn id="34" presetID="42" presetClass="path" presetSubtype="0" accel="50000" decel="50000" fill="hold" nodeType="withEffect">
+                                <p:cTn id="40" presetID="42" presetClass="path" presetSubtype="0" accel="50000" decel="50000" fill="hold" nodeType="withEffect">
                                   <p:stCondLst>
                                     <p:cond delay="0"/>
                                   </p:stCondLst>
                                   <p:childTnLst>
                                     <p:animMotion origin="layout" path="M -4.375E-6 4.81481E-6 L -4.375E-6 0.18773 " pathEditMode="relative" rAng="0" ptsTypes="AA">
                                       <p:cBhvr>
-                                        <p:cTn id="35" dur="2000" fill="hold"/>
+                                        <p:cTn id="41" dur="2000" fill="hold"/>
                                         <p:tgtEl>
                                           <p:spTgt spid="34"/>
                                         </p:tgtEl>
@@ -15982,14 +16166,14 @@
                                 </p:cTn>
                               </p:par>
                               <p:par>
-                                <p:cTn id="36" presetID="42" presetClass="path" presetSubtype="0" accel="50000" decel="50000" fill="hold" nodeType="withEffect">
+                                <p:cTn id="42" presetID="42" presetClass="path" presetSubtype="0" accel="50000" decel="50000" fill="hold" nodeType="withEffect">
                                   <p:stCondLst>
                                     <p:cond delay="0"/>
                                   </p:stCondLst>
                                   <p:childTnLst>
                                     <p:animMotion origin="layout" path="M -4.375E-6 -4.07407E-6 L -4.375E-6 0.10232 " pathEditMode="relative" rAng="0" ptsTypes="AA">
                                       <p:cBhvr>
-                                        <p:cTn id="37" dur="2000" fill="hold"/>
+                                        <p:cTn id="43" dur="2000" fill="hold"/>
                                         <p:tgtEl>
                                           <p:spTgt spid="35"/>
                                         </p:tgtEl>
@@ -16000,78 +16184,6 @@
                                       </p:cBhvr>
                                       <p:rCtr x="0" y="5116"/>
                                     </p:animMotion>
-                                  </p:childTnLst>
-                                </p:cTn>
-                              </p:par>
-                            </p:childTnLst>
-                          </p:cTn>
-                        </p:par>
-                        <p:par>
-                          <p:cTn id="38" fill="hold">
-                            <p:stCondLst>
-                              <p:cond delay="2000"/>
-                            </p:stCondLst>
-                            <p:childTnLst>
-                              <p:par>
-                                <p:cTn id="39" presetID="1" presetClass="exit" presetSubtype="0" fill="hold" grpId="2" nodeType="afterEffect">
-                                  <p:stCondLst>
-                                    <p:cond delay="0"/>
-                                  </p:stCondLst>
-                                  <p:childTnLst>
-                                    <p:set>
-                                      <p:cBhvr>
-                                        <p:cTn id="40" dur="1" fill="hold">
-                                          <p:stCondLst>
-                                            <p:cond delay="0"/>
-                                          </p:stCondLst>
-                                        </p:cTn>
-                                        <p:tgtEl>
-                                          <p:spTgt spid="25"/>
-                                        </p:tgtEl>
-                                        <p:attrNameLst>
-                                          <p:attrName>style.visibility</p:attrName>
-                                        </p:attrNameLst>
-                                      </p:cBhvr>
-                                      <p:to>
-                                        <p:strVal val="hidden"/>
-                                      </p:to>
-                                    </p:set>
-                                  </p:childTnLst>
-                                </p:cTn>
-                              </p:par>
-                            </p:childTnLst>
-                          </p:cTn>
-                        </p:par>
-                        <p:par>
-                          <p:cTn id="41" fill="hold">
-                            <p:stCondLst>
-                              <p:cond delay="2000"/>
-                            </p:stCondLst>
-                            <p:childTnLst>
-                              <p:par>
-                                <p:cTn id="42" presetID="1" presetClass="exit" presetSubtype="0" fill="hold" grpId="2" nodeType="afterEffect">
-                                  <p:stCondLst>
-                                    <p:cond delay="0"/>
-                                  </p:stCondLst>
-                                  <p:childTnLst>
-                                    <p:set>
-                                      <p:cBhvr>
-                                        <p:cTn id="43" dur="1" fill="hold">
-                                          <p:stCondLst>
-                                            <p:cond delay="0"/>
-                                          </p:stCondLst>
-                                        </p:cTn>
-                                        <p:tgtEl>
-                                          <p:spTgt spid="23"/>
-                                        </p:tgtEl>
-                                        <p:attrNameLst>
-                                          <p:attrName>style.visibility</p:attrName>
-                                        </p:attrNameLst>
-                                      </p:cBhvr>
-                                      <p:to>
-                                        <p:strVal val="hidden"/>
-                                      </p:to>
-                                    </p:set>
                                   </p:childTnLst>
                                 </p:cTn>
                               </p:par>
@@ -16085,7 +16197,7 @@
                             </p:stCondLst>
                             <p:childTnLst>
                               <p:par>
-                                <p:cTn id="45" presetID="1" presetClass="exit" presetSubtype="0" fill="hold" nodeType="afterEffect">
+                                <p:cTn id="45" presetID="1" presetClass="exit" presetSubtype="0" fill="hold" grpId="2" nodeType="afterEffect">
                                   <p:stCondLst>
                                     <p:cond delay="0"/>
                                   </p:stCondLst>
@@ -16098,7 +16210,7 @@
                                           </p:stCondLst>
                                         </p:cTn>
                                         <p:tgtEl>
-                                          <p:spTgt spid="34"/>
+                                          <p:spTgt spid="25"/>
                                         </p:tgtEl>
                                         <p:attrNameLst>
                                           <p:attrName>style.visibility</p:attrName>
@@ -16121,7 +16233,7 @@
                             </p:stCondLst>
                             <p:childTnLst>
                               <p:par>
-                                <p:cTn id="48" presetID="1" presetClass="exit" presetSubtype="0" fill="hold" nodeType="afterEffect">
+                                <p:cTn id="48" presetID="1" presetClass="exit" presetSubtype="0" fill="hold" grpId="2" nodeType="afterEffect">
                                   <p:stCondLst>
                                     <p:cond delay="0"/>
                                   </p:stCondLst>
@@ -16129,6 +16241,78 @@
                                     <p:set>
                                       <p:cBhvr>
                                         <p:cTn id="49" dur="1" fill="hold">
+                                          <p:stCondLst>
+                                            <p:cond delay="0"/>
+                                          </p:stCondLst>
+                                        </p:cTn>
+                                        <p:tgtEl>
+                                          <p:spTgt spid="23"/>
+                                        </p:tgtEl>
+                                        <p:attrNameLst>
+                                          <p:attrName>style.visibility</p:attrName>
+                                        </p:attrNameLst>
+                                      </p:cBhvr>
+                                      <p:to>
+                                        <p:strVal val="hidden"/>
+                                      </p:to>
+                                    </p:set>
+                                  </p:childTnLst>
+                                </p:cTn>
+                              </p:par>
+                            </p:childTnLst>
+                          </p:cTn>
+                        </p:par>
+                        <p:par>
+                          <p:cTn id="50" fill="hold">
+                            <p:stCondLst>
+                              <p:cond delay="2000"/>
+                            </p:stCondLst>
+                            <p:childTnLst>
+                              <p:par>
+                                <p:cTn id="51" presetID="1" presetClass="exit" presetSubtype="0" fill="hold" nodeType="afterEffect">
+                                  <p:stCondLst>
+                                    <p:cond delay="0"/>
+                                  </p:stCondLst>
+                                  <p:childTnLst>
+                                    <p:set>
+                                      <p:cBhvr>
+                                        <p:cTn id="52" dur="1" fill="hold">
+                                          <p:stCondLst>
+                                            <p:cond delay="0"/>
+                                          </p:stCondLst>
+                                        </p:cTn>
+                                        <p:tgtEl>
+                                          <p:spTgt spid="34"/>
+                                        </p:tgtEl>
+                                        <p:attrNameLst>
+                                          <p:attrName>style.visibility</p:attrName>
+                                        </p:attrNameLst>
+                                      </p:cBhvr>
+                                      <p:to>
+                                        <p:strVal val="hidden"/>
+                                      </p:to>
+                                    </p:set>
+                                  </p:childTnLst>
+                                </p:cTn>
+                              </p:par>
+                            </p:childTnLst>
+                          </p:cTn>
+                        </p:par>
+                        <p:par>
+                          <p:cTn id="53" fill="hold">
+                            <p:stCondLst>
+                              <p:cond delay="2000"/>
+                            </p:stCondLst>
+                            <p:childTnLst>
+                              <p:par>
+                                <p:cTn id="54" presetID="1" presetClass="exit" presetSubtype="0" fill="hold" nodeType="afterEffect">
+                                  <p:stCondLst>
+                                    <p:cond delay="0"/>
+                                  </p:stCondLst>
+                                  <p:childTnLst>
+                                    <p:set>
+                                      <p:cBhvr>
+                                        <p:cTn id="55" dur="1" fill="hold">
                                           <p:stCondLst>
                                             <p:cond delay="0"/>
                                           </p:stCondLst>
@@ -16148,14 +16332,14 @@
                                 </p:cTn>
                               </p:par>
                               <p:par>
-                                <p:cTn id="50" presetID="1" presetClass="entr" presetSubtype="0" fill="hold" nodeType="withEffect">
+                                <p:cTn id="56" presetID="1" presetClass="entr" presetSubtype="0" fill="hold" nodeType="withEffect">
                                   <p:stCondLst>
                                     <p:cond delay="0"/>
                                   </p:stCondLst>
                                   <p:childTnLst>
                                     <p:set>
                                       <p:cBhvr>
-                                        <p:cTn id="51" dur="1" fill="hold">
+                                        <p:cTn id="57" dur="1" fill="hold">
                                           <p:stCondLst>
                                             <p:cond delay="0"/>
                                           </p:stCondLst>
@@ -16208,6 +16392,7 @@
       <p:bldP spid="25" grpId="0" animBg="1"/>
       <p:bldP spid="25" grpId="1" animBg="1"/>
       <p:bldP spid="25" grpId="2" animBg="1"/>
+      <p:bldP spid="15" grpId="0"/>
     </p:bldLst>
   </p:timing>
 </p:sld>
@@ -16250,7 +16435,7 @@
         </p:nvSpPr>
         <p:spPr>
           <a:xfrm>
-            <a:off x="331872" y="2282620"/>
+            <a:off x="331872" y="4852719"/>
             <a:ext cx="2887578" cy="714377"/>
           </a:xfrm>
           <a:prstGeom prst="roundRect">
@@ -16364,7 +16549,7 @@
             <a:lstStyle/>
             <a:p>
               <a:pPr algn="ctr"/>
-              <a:endParaRPr lang="en-CA"/>
+              <a:endParaRPr lang="en-CA" dirty="0"/>
             </a:p>
           </p:txBody>
         </p:sp>
@@ -16962,7 +17147,7 @@
           <p:nvPr>
             <p:extLst>
               <p:ext uri="{D42A27DB-BD31-4B8C-83A1-F6EECF244321}">
-                <p14:modId xmlns:p14="http://schemas.microsoft.com/office/powerpoint/2010/main" val="1599146616"/>
+                <p14:modId xmlns:p14="http://schemas.microsoft.com/office/powerpoint/2010/main" val="22152950"/>
               </p:ext>
             </p:extLst>
           </p:nvPr>
@@ -17013,7 +17198,10 @@
                     <a:bodyPr/>
                     <a:lstStyle/>
                     <a:p>
-                      <a:endParaRPr lang="en-CA" dirty="0"/>
+                      <a:endParaRPr lang="en-CA" b="0" dirty="0">
+                        <a:latin typeface="Kumbh Sans SemiBold" pitchFamily="2" charset="0"/>
+                        <a:cs typeface="Kumbh Sans SemiBold" pitchFamily="2" charset="0"/>
+                      </a:endParaRPr>
                     </a:p>
                   </a:txBody>
                   <a:tcPr>
@@ -17059,10 +17247,16 @@
                     <a:p>
                       <a:pPr algn="ctr"/>
                       <a:r>
-                        <a:rPr lang="en-CA" dirty="0" err="1"/>
+                        <a:rPr lang="en-CA" b="0" dirty="0" err="1">
+                          <a:latin typeface="Kumbh Sans SemiBold" pitchFamily="2" charset="0"/>
+                          <a:cs typeface="Kumbh Sans SemiBold" pitchFamily="2" charset="0"/>
+                        </a:rPr>
                         <a:t>MasterControl</a:t>
                       </a:r>
-                      <a:endParaRPr lang="en-CA" dirty="0"/>
+                      <a:endParaRPr lang="en-CA" b="0" dirty="0">
+                        <a:latin typeface="Kumbh Sans SemiBold" pitchFamily="2" charset="0"/>
+                        <a:cs typeface="Kumbh Sans SemiBold" pitchFamily="2" charset="0"/>
+                      </a:endParaRPr>
                     </a:p>
                   </a:txBody>
                   <a:tcPr anchor="ctr">
@@ -17118,10 +17312,16 @@
                     <a:p>
                       <a:pPr algn="ctr"/>
                       <a:r>
-                        <a:rPr lang="en-CA" dirty="0" err="1"/>
+                        <a:rPr lang="en-CA" b="0" dirty="0" err="1">
+                          <a:latin typeface="Kumbh Sans SemiBold" pitchFamily="2" charset="0"/>
+                          <a:cs typeface="Kumbh Sans SemiBold" pitchFamily="2" charset="0"/>
+                        </a:rPr>
                         <a:t>Mitti</a:t>
                       </a:r>
-                      <a:endParaRPr lang="en-CA" dirty="0"/>
+                      <a:endParaRPr lang="en-CA" b="0" dirty="0">
+                        <a:latin typeface="Kumbh Sans SemiBold" pitchFamily="2" charset="0"/>
+                        <a:cs typeface="Kumbh Sans SemiBold" pitchFamily="2" charset="0"/>
+                      </a:endParaRPr>
                     </a:p>
                   </a:txBody>
                   <a:tcPr anchor="ctr">
@@ -17179,7 +17379,10 @@
                     <a:p>
                       <a:pPr algn="ctr"/>
                       <a:r>
-                        <a:rPr lang="en-CA" dirty="0"/>
+                        <a:rPr lang="en-CA" b="0" dirty="0">
+                          <a:latin typeface="Kumbh Sans SemiBold" pitchFamily="2" charset="0"/>
+                          <a:cs typeface="Kumbh Sans SemiBold" pitchFamily="2" charset="0"/>
+                        </a:rPr>
                         <a:t>NCR Manager</a:t>
                       </a:r>
                     </a:p>
@@ -17244,7 +17447,10 @@
                     <a:p>
                       <a:pPr algn="ctr"/>
                       <a:r>
-                        <a:rPr lang="en-CA" dirty="0"/>
+                        <a:rPr lang="en-CA" b="0" dirty="0">
+                          <a:latin typeface="Kumbh Sans SemiBold" pitchFamily="2" charset="0"/>
+                          <a:cs typeface="Kumbh Sans SemiBold" pitchFamily="2" charset="0"/>
+                        </a:rPr>
                         <a:t>Setup Time</a:t>
                       </a:r>
                     </a:p>
@@ -17304,7 +17510,10 @@
                     <a:p>
                       <a:pPr algn="ctr"/>
                       <a:r>
-                        <a:rPr lang="en-CA" b="1" dirty="0"/>
+                        <a:rPr lang="en-CA" b="0" dirty="0">
+                          <a:latin typeface="Kumbh Sans SemiBold" pitchFamily="2" charset="0"/>
+                          <a:cs typeface="Kumbh Sans SemiBold" pitchFamily="2" charset="0"/>
+                        </a:rPr>
                         <a:t>1 – 3 Months</a:t>
                       </a:r>
                     </a:p>
@@ -17363,7 +17572,10 @@
                     <a:p>
                       <a:pPr algn="ctr"/>
                       <a:r>
-                        <a:rPr lang="en-CA" b="1" dirty="0"/>
+                        <a:rPr lang="en-CA" b="0" dirty="0">
+                          <a:latin typeface="Kumbh Sans SemiBold" pitchFamily="2" charset="0"/>
+                          <a:cs typeface="Kumbh Sans SemiBold" pitchFamily="2" charset="0"/>
+                        </a:rPr>
                         <a:t>8 Weeks</a:t>
                       </a:r>
                     </a:p>
@@ -17422,7 +17634,10 @@
                     <a:p>
                       <a:pPr algn="ctr"/>
                       <a:r>
-                        <a:rPr lang="en-CA" b="1" dirty="0"/>
+                        <a:rPr lang="en-CA" b="0" dirty="0">
+                          <a:latin typeface="Kumbh Sans SemiBold" pitchFamily="2" charset="0"/>
+                          <a:cs typeface="Kumbh Sans SemiBold" pitchFamily="2" charset="0"/>
+                        </a:rPr>
                         <a:t>4 - 5 Weeks</a:t>
                       </a:r>
                     </a:p>
@@ -17486,7 +17701,10 @@
                     <a:p>
                       <a:pPr algn="ctr"/>
                       <a:r>
-                        <a:rPr lang="en-CA" dirty="0"/>
+                        <a:rPr lang="en-CA" b="0" dirty="0">
+                          <a:latin typeface="Kumbh Sans SemiBold" pitchFamily="2" charset="0"/>
+                          <a:cs typeface="Kumbh Sans SemiBold" pitchFamily="2" charset="0"/>
+                        </a:rPr>
                         <a:t>Training Time</a:t>
                       </a:r>
                     </a:p>
@@ -17546,7 +17764,10 @@
                     <a:p>
                       <a:pPr algn="ctr"/>
                       <a:r>
-                        <a:rPr lang="en-CA" b="1" dirty="0"/>
+                        <a:rPr lang="en-CA" b="0" dirty="0">
+                          <a:latin typeface="Kumbh Sans SemiBold" pitchFamily="2" charset="0"/>
+                          <a:cs typeface="Kumbh Sans SemiBold" pitchFamily="2" charset="0"/>
+                        </a:rPr>
                         <a:t>1 Month</a:t>
                       </a:r>
                     </a:p>
@@ -17605,7 +17826,10 @@
                     <a:p>
                       <a:pPr algn="ctr"/>
                       <a:r>
-                        <a:rPr lang="en-CA" b="1" dirty="0"/>
+                        <a:rPr lang="en-CA" b="0" dirty="0">
+                          <a:latin typeface="Kumbh Sans SemiBold" pitchFamily="2" charset="0"/>
+                          <a:cs typeface="Kumbh Sans SemiBold" pitchFamily="2" charset="0"/>
+                        </a:rPr>
                         <a:t>1 Month</a:t>
                       </a:r>
                     </a:p>
@@ -17664,7 +17888,10 @@
                     <a:p>
                       <a:pPr algn="ctr"/>
                       <a:r>
-                        <a:rPr lang="en-CA" b="1" dirty="0"/>
+                        <a:rPr lang="en-CA" b="0" dirty="0">
+                          <a:latin typeface="Kumbh Sans SemiBold" pitchFamily="2" charset="0"/>
+                          <a:cs typeface="Kumbh Sans SemiBold" pitchFamily="2" charset="0"/>
+                        </a:rPr>
                         <a:t>1 Month</a:t>
                       </a:r>
                     </a:p>
@@ -17728,7 +17955,10 @@
                     <a:p>
                       <a:pPr algn="ctr"/>
                       <a:r>
-                        <a:rPr lang="en-CA" dirty="0"/>
+                        <a:rPr lang="en-CA" b="0" dirty="0">
+                          <a:latin typeface="Kumbh Sans SemiBold" pitchFamily="2" charset="0"/>
+                          <a:cs typeface="Kumbh Sans SemiBold" pitchFamily="2" charset="0"/>
+                        </a:rPr>
                         <a:t>Optional AI</a:t>
                       </a:r>
                     </a:p>
@@ -17788,13 +18018,15 @@
                     <a:p>
                       <a:pPr algn="ctr"/>
                       <a:r>
-                        <a:rPr lang="en-CA" b="1" dirty="0">
+                        <a:rPr lang="en-CA" b="0" dirty="0">
                           <a:solidFill>
                             <a:schemeClr val="accent1">
                               <a:lumMod val="60000"/>
                               <a:lumOff val="40000"/>
                             </a:schemeClr>
                           </a:solidFill>
+                          <a:latin typeface="Kumbh Sans SemiBold" pitchFamily="2" charset="0"/>
+                          <a:cs typeface="Kumbh Sans SemiBold" pitchFamily="2" charset="0"/>
                         </a:rPr>
                         <a:t>No</a:t>
                       </a:r>
@@ -17854,13 +18086,15 @@
                     <a:p>
                       <a:pPr algn="ctr"/>
                       <a:r>
-                        <a:rPr lang="en-CA" b="1" dirty="0">
+                        <a:rPr lang="en-CA" b="0" dirty="0">
                           <a:solidFill>
                             <a:schemeClr val="accent1">
                               <a:lumMod val="60000"/>
                               <a:lumOff val="40000"/>
                             </a:schemeClr>
                           </a:solidFill>
+                          <a:latin typeface="Kumbh Sans SemiBold" pitchFamily="2" charset="0"/>
+                          <a:cs typeface="Kumbh Sans SemiBold" pitchFamily="2" charset="0"/>
                         </a:rPr>
                         <a:t>No</a:t>
                       </a:r>
@@ -17920,10 +18154,12 @@
                     <a:p>
                       <a:pPr algn="ctr"/>
                       <a:r>
-                        <a:rPr lang="en-CA" b="1" dirty="0">
+                        <a:rPr lang="en-CA" b="0" dirty="0">
                           <a:solidFill>
                             <a:schemeClr val="accent6"/>
                           </a:solidFill>
+                          <a:latin typeface="Kumbh Sans SemiBold" pitchFamily="2" charset="0"/>
+                          <a:cs typeface="Kumbh Sans SemiBold" pitchFamily="2" charset="0"/>
                         </a:rPr>
                         <a:t>Yes</a:t>
                       </a:r>
@@ -17988,7 +18224,10 @@
                     <a:p>
                       <a:pPr algn="ctr"/>
                       <a:r>
-                        <a:rPr lang="en-CA" dirty="0"/>
+                        <a:rPr lang="en-CA" b="0" dirty="0">
+                          <a:latin typeface="Kumbh Sans SemiBold" pitchFamily="2" charset="0"/>
+                          <a:cs typeface="Kumbh Sans SemiBold" pitchFamily="2" charset="0"/>
+                        </a:rPr>
                         <a:t>Your Data</a:t>
                       </a:r>
                     </a:p>
@@ -18048,13 +18287,15 @@
                     <a:p>
                       <a:pPr algn="ctr"/>
                       <a:r>
-                        <a:rPr lang="en-CA" b="1" dirty="0">
+                        <a:rPr lang="en-CA" b="0" dirty="0">
                           <a:solidFill>
                             <a:schemeClr val="accent1">
                               <a:lumMod val="60000"/>
                               <a:lumOff val="40000"/>
                             </a:schemeClr>
                           </a:solidFill>
+                          <a:latin typeface="Kumbh Sans SemiBold" pitchFamily="2" charset="0"/>
+                          <a:cs typeface="Kumbh Sans SemiBold" pitchFamily="2" charset="0"/>
                         </a:rPr>
                         <a:t>No</a:t>
                       </a:r>
@@ -18114,13 +18355,15 @@
                     <a:p>
                       <a:pPr algn="ctr"/>
                       <a:r>
-                        <a:rPr lang="en-CA" b="1" dirty="0">
+                        <a:rPr lang="en-CA" b="0" dirty="0">
                           <a:solidFill>
                             <a:schemeClr val="accent1">
                               <a:lumMod val="60000"/>
                               <a:lumOff val="40000"/>
                             </a:schemeClr>
                           </a:solidFill>
+                          <a:latin typeface="Kumbh Sans SemiBold" pitchFamily="2" charset="0"/>
+                          <a:cs typeface="Kumbh Sans SemiBold" pitchFamily="2" charset="0"/>
                         </a:rPr>
                         <a:t>No</a:t>
                       </a:r>
@@ -18180,10 +18423,12 @@
                     <a:p>
                       <a:pPr algn="ctr"/>
                       <a:r>
-                        <a:rPr lang="en-CA" b="1" dirty="0">
+                        <a:rPr lang="en-CA" b="0" dirty="0">
                           <a:solidFill>
                             <a:schemeClr val="accent6"/>
                           </a:solidFill>
+                          <a:latin typeface="Kumbh Sans SemiBold" pitchFamily="2" charset="0"/>
+                          <a:cs typeface="Kumbh Sans SemiBold" pitchFamily="2" charset="0"/>
                         </a:rPr>
                         <a:t>Yes</a:t>
                       </a:r>
@@ -18248,7 +18493,10 @@
                     <a:p>
                       <a:pPr algn="ctr"/>
                       <a:r>
-                        <a:rPr lang="en-CA" dirty="0"/>
+                        <a:rPr lang="en-CA" b="0" dirty="0">
+                          <a:latin typeface="Kumbh Sans SemiBold" pitchFamily="2" charset="0"/>
+                          <a:cs typeface="Kumbh Sans SemiBold" pitchFamily="2" charset="0"/>
+                        </a:rPr>
                         <a:t>Price</a:t>
                       </a:r>
                     </a:p>
@@ -18306,7 +18554,10 @@
                     <a:p>
                       <a:pPr algn="ctr"/>
                       <a:r>
-                        <a:rPr lang="en-CA" b="1" dirty="0"/>
+                        <a:rPr lang="en-CA" b="0" dirty="0">
+                          <a:latin typeface="Kumbh Sans SemiBold" pitchFamily="2" charset="0"/>
+                          <a:cs typeface="Kumbh Sans SemiBold" pitchFamily="2" charset="0"/>
+                        </a:rPr>
                         <a:t>$21,000</a:t>
                       </a:r>
                     </a:p>
@@ -18363,7 +18614,10 @@
                     <a:p>
                       <a:pPr algn="ctr"/>
                       <a:r>
-                        <a:rPr lang="en-CA" b="1" dirty="0"/>
+                        <a:rPr lang="en-CA" b="0" dirty="0">
+                          <a:latin typeface="Kumbh Sans SemiBold" pitchFamily="2" charset="0"/>
+                          <a:cs typeface="Kumbh Sans SemiBold" pitchFamily="2" charset="0"/>
+                        </a:rPr>
                         <a:t>$1,728</a:t>
                       </a:r>
                     </a:p>
@@ -18420,7 +18674,10 @@
                     <a:p>
                       <a:pPr algn="ctr"/>
                       <a:r>
-                        <a:rPr lang="en-CA" b="1" dirty="0"/>
+                        <a:rPr lang="en-CA" b="0" dirty="0">
+                          <a:latin typeface="Kumbh Sans SemiBold" pitchFamily="2" charset="0"/>
+                          <a:cs typeface="Kumbh Sans SemiBold" pitchFamily="2" charset="0"/>
+                        </a:rPr>
                         <a:t>$500</a:t>
                       </a:r>
                     </a:p>
@@ -18987,42 +19244,43 @@
                             </p:stCondLst>
                             <p:childTnLst>
                               <p:par>
-                                <p:cTn id="5" presetID="42" presetClass="path" presetSubtype="0" accel="50000" decel="50000" fill="hold" nodeType="clickEffect">
+                                <p:cTn id="5" presetID="1" presetClass="entr" presetSubtype="0" fill="hold" grpId="0" nodeType="clickEffect">
                                   <p:stCondLst>
                                     <p:cond delay="0"/>
                                   </p:stCondLst>
                                   <p:childTnLst>
-                                    <p:animMotion origin="layout" path="M -2.29167E-6 -2.22222E-6 L -2.29167E-6 -0.37523 " pathEditMode="relative" rAng="0" ptsTypes="AA">
-                                      <p:cBhvr>
-                                        <p:cTn id="6" dur="2000" fill="hold"/>
-                                        <p:tgtEl>
-                                          <p:spTgt spid="3"/>
-                                        </p:tgtEl>
-                                        <p:attrNameLst>
-                                          <p:attrName>ppt_x</p:attrName>
-                                          <p:attrName>ppt_y</p:attrName>
-                                        </p:attrNameLst>
-                                      </p:cBhvr>
-                                      <p:rCtr x="0" y="-18773"/>
-                                    </p:animMotion>
+                                    <p:set>
+                                      <p:cBhvr>
+                                        <p:cTn id="6" dur="1" fill="hold">
+                                          <p:stCondLst>
+                                            <p:cond delay="0"/>
+                                          </p:stCondLst>
+                                        </p:cTn>
+                                        <p:tgtEl>
+                                          <p:spTgt spid="6"/>
+                                        </p:tgtEl>
+                                        <p:attrNameLst>
+                                          <p:attrName>style.visibility</p:attrName>
+                                        </p:attrNameLst>
+                                      </p:cBhvr>
+                                      <p:to>
+                                        <p:strVal val="visible"/>
+                                      </p:to>
+                                    </p:set>
                                   </p:childTnLst>
                                 </p:cTn>
                               </p:par>
                               <p:par>
-                                <p:cTn id="7" presetID="22" presetClass="exit" presetSubtype="4" fill="hold" nodeType="withEffect">
+                                <p:cTn id="7" presetID="10" presetClass="exit" presetSubtype="0" fill="hold" grpId="0" nodeType="withEffect">
                                   <p:stCondLst>
-                                    <p:cond delay="300"/>
+                                    <p:cond delay="0"/>
                                   </p:stCondLst>
                                   <p:childTnLst>
-                                    <p:animEffect transition="out" filter="wipe(down)">
-                                      <p:cBhvr>
-                                        <p:cTn id="8" dur="300"/>
-                                        <p:tgtEl>
-                                          <p:spTgt spid="2">
-                                            <p:txEl>
-                                              <p:pRg st="6" end="6"/>
-                                            </p:txEl>
-                                          </p:spTgt>
+                                    <p:animEffect transition="out" filter="fade">
+                                      <p:cBhvr>
+                                        <p:cTn id="8" dur="500"/>
+                                        <p:tgtEl>
+                                          <p:spTgt spid="13"/>
                                         </p:tgtEl>
                                       </p:cBhvr>
                                     </p:animEffect>
@@ -19030,15 +19288,11 @@
                                       <p:cBhvr>
                                         <p:cTn id="9" dur="1" fill="hold">
                                           <p:stCondLst>
-                                            <p:cond delay="299"/>
+                                            <p:cond delay="499"/>
                                           </p:stCondLst>
                                         </p:cTn>
                                         <p:tgtEl>
-                                          <p:spTgt spid="2">
-                                            <p:txEl>
-                                              <p:pRg st="6" end="6"/>
-                                            </p:txEl>
-                                          </p:spTgt>
+                                          <p:spTgt spid="13"/>
                                         </p:tgtEl>
                                         <p:attrNameLst>
                                           <p:attrName>style.visibility</p:attrName>
@@ -19052,20 +19306,16 @@
                                 </p:cTn>
                               </p:par>
                               <p:par>
-                                <p:cTn id="10" presetID="22" presetClass="exit" presetSubtype="4" fill="hold" nodeType="withEffect">
+                                <p:cTn id="10" presetID="10" presetClass="exit" presetSubtype="0" fill="hold" nodeType="withEffect">
                                   <p:stCondLst>
-                                    <p:cond delay="500"/>
+                                    <p:cond delay="0"/>
                                   </p:stCondLst>
                                   <p:childTnLst>
-                                    <p:animEffect transition="out" filter="wipe(down)">
-                                      <p:cBhvr>
-                                        <p:cTn id="11" dur="300"/>
-                                        <p:tgtEl>
-                                          <p:spTgt spid="2">
-                                            <p:txEl>
-                                              <p:pRg st="5" end="5"/>
-                                            </p:txEl>
-                                          </p:spTgt>
+                                    <p:animEffect transition="out" filter="fade">
+                                      <p:cBhvr>
+                                        <p:cTn id="11" dur="500"/>
+                                        <p:tgtEl>
+                                          <p:spTgt spid="3"/>
                                         </p:tgtEl>
                                       </p:cBhvr>
                                     </p:animEffect>
@@ -19073,15 +19323,11 @@
                                       <p:cBhvr>
                                         <p:cTn id="12" dur="1" fill="hold">
                                           <p:stCondLst>
-                                            <p:cond delay="299"/>
+                                            <p:cond delay="499"/>
                                           </p:stCondLst>
                                         </p:cTn>
                                         <p:tgtEl>
-                                          <p:spTgt spid="2">
-                                            <p:txEl>
-                                              <p:pRg st="5" end="5"/>
-                                            </p:txEl>
-                                          </p:spTgt>
+                                          <p:spTgt spid="3"/>
                                         </p:tgtEl>
                                         <p:attrNameLst>
                                           <p:attrName>style.visibility</p:attrName>
@@ -19095,20 +19341,16 @@
                                 </p:cTn>
                               </p:par>
                               <p:par>
-                                <p:cTn id="13" presetID="22" presetClass="exit" presetSubtype="4" fill="hold" nodeType="withEffect">
+                                <p:cTn id="13" presetID="10" presetClass="exit" presetSubtype="0" fill="hold" nodeType="withEffect">
                                   <p:stCondLst>
-                                    <p:cond delay="800"/>
+                                    <p:cond delay="0"/>
                                   </p:stCondLst>
                                   <p:childTnLst>
-                                    <p:animEffect transition="out" filter="wipe(down)">
-                                      <p:cBhvr>
-                                        <p:cTn id="14" dur="300"/>
-                                        <p:tgtEl>
-                                          <p:spTgt spid="2">
-                                            <p:txEl>
-                                              <p:pRg st="4" end="4"/>
-                                            </p:txEl>
-                                          </p:spTgt>
+                                    <p:animEffect transition="out" filter="fade">
+                                      <p:cBhvr>
+                                        <p:cTn id="14" dur="500"/>
+                                        <p:tgtEl>
+                                          <p:spTgt spid="21"/>
                                         </p:tgtEl>
                                       </p:cBhvr>
                                     </p:animEffect>
@@ -19116,15 +19358,11 @@
                                       <p:cBhvr>
                                         <p:cTn id="15" dur="1" fill="hold">
                                           <p:stCondLst>
-                                            <p:cond delay="299"/>
+                                            <p:cond delay="499"/>
                                           </p:stCondLst>
                                         </p:cTn>
                                         <p:tgtEl>
-                                          <p:spTgt spid="2">
-                                            <p:txEl>
-                                              <p:pRg st="4" end="4"/>
-                                            </p:txEl>
-                                          </p:spTgt>
+                                          <p:spTgt spid="21"/>
                                         </p:tgtEl>
                                         <p:attrNameLst>
                                           <p:attrName>style.visibility</p:attrName>
@@ -19138,20 +19376,16 @@
                                 </p:cTn>
                               </p:par>
                               <p:par>
-                                <p:cTn id="16" presetID="22" presetClass="exit" presetSubtype="4" fill="hold" nodeType="withEffect">
+                                <p:cTn id="16" presetID="10" presetClass="exit" presetSubtype="0" fill="hold" nodeType="withEffect">
                                   <p:stCondLst>
-                                    <p:cond delay="1000"/>
+                                    <p:cond delay="0"/>
                                   </p:stCondLst>
                                   <p:childTnLst>
-                                    <p:animEffect transition="out" filter="wipe(down)">
-                                      <p:cBhvr>
-                                        <p:cTn id="17" dur="300"/>
-                                        <p:tgtEl>
-                                          <p:spTgt spid="2">
-                                            <p:txEl>
-                                              <p:pRg st="3" end="3"/>
-                                            </p:txEl>
-                                          </p:spTgt>
+                                    <p:animEffect transition="out" filter="fade">
+                                      <p:cBhvr>
+                                        <p:cTn id="17" dur="500"/>
+                                        <p:tgtEl>
+                                          <p:spTgt spid="27"/>
                                         </p:tgtEl>
                                       </p:cBhvr>
                                     </p:animEffect>
@@ -19159,15 +19393,11 @@
                                       <p:cBhvr>
                                         <p:cTn id="18" dur="1" fill="hold">
                                           <p:stCondLst>
-                                            <p:cond delay="299"/>
+                                            <p:cond delay="499"/>
                                           </p:stCondLst>
                                         </p:cTn>
                                         <p:tgtEl>
-                                          <p:spTgt spid="2">
-                                            <p:txEl>
-                                              <p:pRg st="3" end="3"/>
-                                            </p:txEl>
-                                          </p:spTgt>
+                                          <p:spTgt spid="27"/>
                                         </p:tgtEl>
                                         <p:attrNameLst>
                                           <p:attrName>style.visibility</p:attrName>
@@ -19181,20 +19411,16 @@
                                 </p:cTn>
                               </p:par>
                               <p:par>
-                                <p:cTn id="19" presetID="22" presetClass="exit" presetSubtype="4" fill="hold" nodeType="withEffect">
+                                <p:cTn id="19" presetID="10" presetClass="exit" presetSubtype="0" fill="hold" nodeType="withEffect">
                                   <p:stCondLst>
-                                    <p:cond delay="1200"/>
+                                    <p:cond delay="0"/>
                                   </p:stCondLst>
                                   <p:childTnLst>
-                                    <p:animEffect transition="out" filter="wipe(down)">
-                                      <p:cBhvr>
-                                        <p:cTn id="20" dur="300"/>
-                                        <p:tgtEl>
-                                          <p:spTgt spid="2">
-                                            <p:txEl>
-                                              <p:pRg st="2" end="2"/>
-                                            </p:txEl>
-                                          </p:spTgt>
+                                    <p:animEffect transition="out" filter="fade">
+                                      <p:cBhvr>
+                                        <p:cTn id="20" dur="500"/>
+                                        <p:tgtEl>
+                                          <p:spTgt spid="24"/>
                                         </p:tgtEl>
                                       </p:cBhvr>
                                     </p:animEffect>
@@ -19202,15 +19428,11 @@
                                       <p:cBhvr>
                                         <p:cTn id="21" dur="1" fill="hold">
                                           <p:stCondLst>
-                                            <p:cond delay="299"/>
+                                            <p:cond delay="499"/>
                                           </p:stCondLst>
                                         </p:cTn>
                                         <p:tgtEl>
-                                          <p:spTgt spid="2">
-                                            <p:txEl>
-                                              <p:pRg st="2" end="2"/>
-                                            </p:txEl>
-                                          </p:spTgt>
+                                          <p:spTgt spid="24"/>
                                         </p:tgtEl>
                                         <p:attrNameLst>
                                           <p:attrName>style.visibility</p:attrName>
@@ -19224,14 +19446,356 @@
                                 </p:cTn>
                               </p:par>
                               <p:par>
-                                <p:cTn id="22" presetID="2" presetClass="entr" presetSubtype="4" decel="100000" fill="hold" nodeType="withEffect">
+                                <p:cTn id="22" presetID="10" presetClass="exit" presetSubtype="0" fill="hold" nodeType="withEffect">
                                   <p:stCondLst>
-                                    <p:cond delay="800"/>
+                                    <p:cond delay="0"/>
+                                  </p:stCondLst>
+                                  <p:childTnLst>
+                                    <p:animEffect transition="out" filter="fade">
+                                      <p:cBhvr>
+                                        <p:cTn id="23" dur="500"/>
+                                        <p:tgtEl>
+                                          <p:spTgt spid="12"/>
+                                        </p:tgtEl>
+                                      </p:cBhvr>
+                                    </p:animEffect>
+                                    <p:set>
+                                      <p:cBhvr>
+                                        <p:cTn id="24" dur="1" fill="hold">
+                                          <p:stCondLst>
+                                            <p:cond delay="499"/>
+                                          </p:stCondLst>
+                                        </p:cTn>
+                                        <p:tgtEl>
+                                          <p:spTgt spid="12"/>
+                                        </p:tgtEl>
+                                        <p:attrNameLst>
+                                          <p:attrName>style.visibility</p:attrName>
+                                        </p:attrNameLst>
+                                      </p:cBhvr>
+                                      <p:to>
+                                        <p:strVal val="hidden"/>
+                                      </p:to>
+                                    </p:set>
+                                  </p:childTnLst>
+                                </p:cTn>
+                              </p:par>
+                              <p:par>
+                                <p:cTn id="25" presetID="10" presetClass="exit" presetSubtype="0" fill="hold" grpId="0" nodeType="withEffect">
+                                  <p:stCondLst>
+                                    <p:cond delay="0"/>
+                                  </p:stCondLst>
+                                  <p:childTnLst>
+                                    <p:animEffect transition="out" filter="fade">
+                                      <p:cBhvr>
+                                        <p:cTn id="26" dur="500"/>
+                                        <p:tgtEl>
+                                          <p:spTgt spid="14"/>
+                                        </p:tgtEl>
+                                      </p:cBhvr>
+                                    </p:animEffect>
+                                    <p:set>
+                                      <p:cBhvr>
+                                        <p:cTn id="27" dur="1" fill="hold">
+                                          <p:stCondLst>
+                                            <p:cond delay="499"/>
+                                          </p:stCondLst>
+                                        </p:cTn>
+                                        <p:tgtEl>
+                                          <p:spTgt spid="14"/>
+                                        </p:tgtEl>
+                                        <p:attrNameLst>
+                                          <p:attrName>style.visibility</p:attrName>
+                                        </p:attrNameLst>
+                                      </p:cBhvr>
+                                      <p:to>
+                                        <p:strVal val="hidden"/>
+                                      </p:to>
+                                    </p:set>
+                                  </p:childTnLst>
+                                </p:cTn>
+                              </p:par>
+                              <p:par>
+                                <p:cTn id="28" presetID="10" presetClass="exit" presetSubtype="0" fill="hold" nodeType="withEffect">
+                                  <p:stCondLst>
+                                    <p:cond delay="0"/>
+                                  </p:stCondLst>
+                                  <p:childTnLst>
+                                    <p:animEffect transition="out" filter="fade">
+                                      <p:cBhvr>
+                                        <p:cTn id="29" dur="500"/>
+                                        <p:tgtEl>
+                                          <p:spTgt spid="3"/>
+                                        </p:tgtEl>
+                                      </p:cBhvr>
+                                    </p:animEffect>
+                                    <p:set>
+                                      <p:cBhvr>
+                                        <p:cTn id="30" dur="1" fill="hold">
+                                          <p:stCondLst>
+                                            <p:cond delay="499"/>
+                                          </p:stCondLst>
+                                        </p:cTn>
+                                        <p:tgtEl>
+                                          <p:spTgt spid="3"/>
+                                        </p:tgtEl>
+                                        <p:attrNameLst>
+                                          <p:attrName>style.visibility</p:attrName>
+                                        </p:attrNameLst>
+                                      </p:cBhvr>
+                                      <p:to>
+                                        <p:strVal val="hidden"/>
+                                      </p:to>
+                                    </p:set>
+                                  </p:childTnLst>
+                                </p:cTn>
+                              </p:par>
+                              <p:par>
+                                <p:cTn id="31" presetID="42" presetClass="path" presetSubtype="0" accel="50000" decel="50000" fill="hold" grpId="1" nodeType="withEffect">
+                                  <p:stCondLst>
+                                    <p:cond delay="300"/>
+                                  </p:stCondLst>
+                                  <p:childTnLst>
+                                    <p:animMotion origin="layout" path="M -2.91667E-6 -2.22222E-6 L -2.91667E-6 -0.37662 " pathEditMode="relative" rAng="0" ptsTypes="AA">
+                                      <p:cBhvr>
+                                        <p:cTn id="32" dur="1700" fill="hold"/>
+                                        <p:tgtEl>
+                                          <p:spTgt spid="6"/>
+                                        </p:tgtEl>
+                                        <p:attrNameLst>
+                                          <p:attrName>ppt_x</p:attrName>
+                                          <p:attrName>ppt_y</p:attrName>
+                                        </p:attrNameLst>
+                                      </p:cBhvr>
+                                      <p:rCtr x="0" y="-18843"/>
+                                    </p:animMotion>
+                                  </p:childTnLst>
+                                </p:cTn>
+                              </p:par>
+                              <p:par>
+                                <p:cTn id="33" presetID="22" presetClass="exit" presetSubtype="4" fill="hold" nodeType="withEffect">
+                                  <p:stCondLst>
+                                    <p:cond delay="500"/>
+                                  </p:stCondLst>
+                                  <p:childTnLst>
+                                    <p:animEffect transition="out" filter="wipe(down)">
+                                      <p:cBhvr>
+                                        <p:cTn id="34" dur="300"/>
+                                        <p:tgtEl>
+                                          <p:spTgt spid="2">
+                                            <p:txEl>
+                                              <p:pRg st="6" end="6"/>
+                                            </p:txEl>
+                                          </p:spTgt>
+                                        </p:tgtEl>
+                                      </p:cBhvr>
+                                    </p:animEffect>
+                                    <p:set>
+                                      <p:cBhvr>
+                                        <p:cTn id="35" dur="1" fill="hold">
+                                          <p:stCondLst>
+                                            <p:cond delay="299"/>
+                                          </p:stCondLst>
+                                        </p:cTn>
+                                        <p:tgtEl>
+                                          <p:spTgt spid="2">
+                                            <p:txEl>
+                                              <p:pRg st="6" end="6"/>
+                                            </p:txEl>
+                                          </p:spTgt>
+                                        </p:tgtEl>
+                                        <p:attrNameLst>
+                                          <p:attrName>style.visibility</p:attrName>
+                                        </p:attrNameLst>
+                                      </p:cBhvr>
+                                      <p:to>
+                                        <p:strVal val="hidden"/>
+                                      </p:to>
+                                    </p:set>
+                                  </p:childTnLst>
+                                </p:cTn>
+                              </p:par>
+                              <p:par>
+                                <p:cTn id="36" presetID="22" presetClass="exit" presetSubtype="4" fill="hold" nodeType="withEffect">
+                                  <p:stCondLst>
+                                    <p:cond delay="700"/>
+                                  </p:stCondLst>
+                                  <p:childTnLst>
+                                    <p:animEffect transition="out" filter="wipe(down)">
+                                      <p:cBhvr>
+                                        <p:cTn id="37" dur="300"/>
+                                        <p:tgtEl>
+                                          <p:spTgt spid="2">
+                                            <p:txEl>
+                                              <p:pRg st="5" end="5"/>
+                                            </p:txEl>
+                                          </p:spTgt>
+                                        </p:tgtEl>
+                                      </p:cBhvr>
+                                    </p:animEffect>
+                                    <p:set>
+                                      <p:cBhvr>
+                                        <p:cTn id="38" dur="1" fill="hold">
+                                          <p:stCondLst>
+                                            <p:cond delay="299"/>
+                                          </p:stCondLst>
+                                        </p:cTn>
+                                        <p:tgtEl>
+                                          <p:spTgt spid="2">
+                                            <p:txEl>
+                                              <p:pRg st="5" end="5"/>
+                                            </p:txEl>
+                                          </p:spTgt>
+                                        </p:tgtEl>
+                                        <p:attrNameLst>
+                                          <p:attrName>style.visibility</p:attrName>
+                                        </p:attrNameLst>
+                                      </p:cBhvr>
+                                      <p:to>
+                                        <p:strVal val="hidden"/>
+                                      </p:to>
+                                    </p:set>
+                                  </p:childTnLst>
+                                </p:cTn>
+                              </p:par>
+                              <p:par>
+                                <p:cTn id="39" presetID="22" presetClass="exit" presetSubtype="4" fill="hold" nodeType="withEffect">
+                                  <p:stCondLst>
+                                    <p:cond delay="1000"/>
+                                  </p:stCondLst>
+                                  <p:childTnLst>
+                                    <p:animEffect transition="out" filter="wipe(down)">
+                                      <p:cBhvr>
+                                        <p:cTn id="40" dur="300"/>
+                                        <p:tgtEl>
+                                          <p:spTgt spid="2">
+                                            <p:txEl>
+                                              <p:pRg st="4" end="4"/>
+                                            </p:txEl>
+                                          </p:spTgt>
+                                        </p:tgtEl>
+                                      </p:cBhvr>
+                                    </p:animEffect>
+                                    <p:set>
+                                      <p:cBhvr>
+                                        <p:cTn id="41" dur="1" fill="hold">
+                                          <p:stCondLst>
+                                            <p:cond delay="299"/>
+                                          </p:stCondLst>
+                                        </p:cTn>
+                                        <p:tgtEl>
+                                          <p:spTgt spid="2">
+                                            <p:txEl>
+                                              <p:pRg st="4" end="4"/>
+                                            </p:txEl>
+                                          </p:spTgt>
+                                        </p:tgtEl>
+                                        <p:attrNameLst>
+                                          <p:attrName>style.visibility</p:attrName>
+                                        </p:attrNameLst>
+                                      </p:cBhvr>
+                                      <p:to>
+                                        <p:strVal val="hidden"/>
+                                      </p:to>
+                                    </p:set>
+                                  </p:childTnLst>
+                                </p:cTn>
+                              </p:par>
+                              <p:par>
+                                <p:cTn id="42" presetID="22" presetClass="exit" presetSubtype="4" fill="hold" nodeType="withEffect">
+                                  <p:stCondLst>
+                                    <p:cond delay="1200"/>
+                                  </p:stCondLst>
+                                  <p:childTnLst>
+                                    <p:animEffect transition="out" filter="wipe(down)">
+                                      <p:cBhvr>
+                                        <p:cTn id="43" dur="300"/>
+                                        <p:tgtEl>
+                                          <p:spTgt spid="2">
+                                            <p:txEl>
+                                              <p:pRg st="3" end="3"/>
+                                            </p:txEl>
+                                          </p:spTgt>
+                                        </p:tgtEl>
+                                      </p:cBhvr>
+                                    </p:animEffect>
+                                    <p:set>
+                                      <p:cBhvr>
+                                        <p:cTn id="44" dur="1" fill="hold">
+                                          <p:stCondLst>
+                                            <p:cond delay="299"/>
+                                          </p:stCondLst>
+                                        </p:cTn>
+                                        <p:tgtEl>
+                                          <p:spTgt spid="2">
+                                            <p:txEl>
+                                              <p:pRg st="3" end="3"/>
+                                            </p:txEl>
+                                          </p:spTgt>
+                                        </p:tgtEl>
+                                        <p:attrNameLst>
+                                          <p:attrName>style.visibility</p:attrName>
+                                        </p:attrNameLst>
+                                      </p:cBhvr>
+                                      <p:to>
+                                        <p:strVal val="hidden"/>
+                                      </p:to>
+                                    </p:set>
+                                  </p:childTnLst>
+                                </p:cTn>
+                              </p:par>
+                              <p:par>
+                                <p:cTn id="45" presetID="22" presetClass="exit" presetSubtype="4" fill="hold" nodeType="withEffect">
+                                  <p:stCondLst>
+                                    <p:cond delay="1400"/>
+                                  </p:stCondLst>
+                                  <p:childTnLst>
+                                    <p:animEffect transition="out" filter="wipe(down)">
+                                      <p:cBhvr>
+                                        <p:cTn id="46" dur="300"/>
+                                        <p:tgtEl>
+                                          <p:spTgt spid="2">
+                                            <p:txEl>
+                                              <p:pRg st="2" end="2"/>
+                                            </p:txEl>
+                                          </p:spTgt>
+                                        </p:tgtEl>
+                                      </p:cBhvr>
+                                    </p:animEffect>
+                                    <p:set>
+                                      <p:cBhvr>
+                                        <p:cTn id="47" dur="1" fill="hold">
+                                          <p:stCondLst>
+                                            <p:cond delay="299"/>
+                                          </p:stCondLst>
+                                        </p:cTn>
+                                        <p:tgtEl>
+                                          <p:spTgt spid="2">
+                                            <p:txEl>
+                                              <p:pRg st="2" end="2"/>
+                                            </p:txEl>
+                                          </p:spTgt>
+                                        </p:tgtEl>
+                                        <p:attrNameLst>
+                                          <p:attrName>style.visibility</p:attrName>
+                                        </p:attrNameLst>
+                                      </p:cBhvr>
+                                      <p:to>
+                                        <p:strVal val="hidden"/>
+                                      </p:to>
+                                    </p:set>
+                                  </p:childTnLst>
+                                </p:cTn>
+                              </p:par>
+                              <p:par>
+                                <p:cTn id="48" presetID="2" presetClass="entr" presetSubtype="4" decel="100000" fill="hold" nodeType="withEffect">
+                                  <p:stCondLst>
+                                    <p:cond delay="700"/>
                                   </p:stCondLst>
                                   <p:childTnLst>
                                     <p:set>
                                       <p:cBhvr>
-                                        <p:cTn id="23" dur="1" fill="hold">
+                                        <p:cTn id="49" dur="1" fill="hold">
                                           <p:stCondLst>
                                             <p:cond delay="0"/>
                                           </p:stCondLst>
@@ -19253,7 +19817,7 @@
                                     </p:set>
                                     <p:anim calcmode="lin" valueType="num">
                                       <p:cBhvr additive="base">
-                                        <p:cTn id="24" dur="1200" fill="hold"/>
+                                        <p:cTn id="50" dur="1400" fill="hold"/>
                                         <p:tgtEl>
                                           <p:spTgt spid="15">
                                             <p:txEl>
@@ -19280,7 +19844,7 @@
                                     </p:anim>
                                     <p:anim calcmode="lin" valueType="num">
                                       <p:cBhvr additive="base">
-                                        <p:cTn id="25" dur="1200" fill="hold"/>
+                                        <p:cTn id="51" dur="1400" fill="hold"/>
                                         <p:tgtEl>
                                           <p:spTgt spid="15">
                                             <p:txEl>
@@ -19309,14 +19873,14 @@
                                 </p:cTn>
                               </p:par>
                               <p:par>
-                                <p:cTn id="26" presetID="19" presetClass="emph" presetSubtype="0" fill="hold" nodeType="withEffect">
+                                <p:cTn id="52" presetID="19" presetClass="emph" presetSubtype="0" fill="hold" nodeType="withEffect">
                                   <p:stCondLst>
                                     <p:cond delay="900"/>
                                   </p:stCondLst>
                                   <p:childTnLst>
                                     <p:animClr clrSpc="rgb" dir="cw">
                                       <p:cBhvr override="childStyle">
-                                        <p:cTn id="27" dur="500" fill="hold"/>
+                                        <p:cTn id="53" dur="500" fill="hold"/>
                                         <p:tgtEl>
                                           <p:spTgt spid="2">
                                             <p:txEl>
@@ -19334,7 +19898,7 @@
                                     </p:animClr>
                                     <p:animClr clrSpc="rgb" dir="cw">
                                       <p:cBhvr>
-                                        <p:cTn id="28" dur="500" fill="hold"/>
+                                        <p:cTn id="54" dur="500" fill="hold"/>
                                         <p:tgtEl>
                                           <p:spTgt spid="2">
                                             <p:txEl>
@@ -19352,7 +19916,7 @@
                                     </p:animClr>
                                     <p:set>
                                       <p:cBhvr>
-                                        <p:cTn id="29" dur="500" fill="hold"/>
+                                        <p:cTn id="55" dur="500" fill="hold"/>
                                         <p:tgtEl>
                                           <p:spTgt spid="2">
                                             <p:txEl>
@@ -19370,7 +19934,7 @@
                                     </p:set>
                                     <p:set>
                                       <p:cBhvr>
-                                        <p:cTn id="30" dur="500" fill="hold"/>
+                                        <p:cTn id="56" dur="500" fill="hold"/>
                                         <p:tgtEl>
                                           <p:spTgt spid="2">
                                             <p:txEl>
@@ -19390,14 +19954,14 @@
                                 </p:cTn>
                               </p:par>
                               <p:par>
-                                <p:cTn id="31" presetID="1" presetClass="exit" presetSubtype="0" fill="hold" nodeType="withEffect">
+                                <p:cTn id="57" presetID="1" presetClass="exit" presetSubtype="0" fill="hold" nodeType="withEffect">
                                   <p:stCondLst>
                                     <p:cond delay="900"/>
                                   </p:stCondLst>
                                   <p:childTnLst>
                                     <p:set>
                                       <p:cBhvr>
-                                        <p:cTn id="32" dur="1" fill="hold">
+                                        <p:cTn id="58" dur="1" fill="hold">
                                           <p:stCondLst>
                                             <p:cond delay="0"/>
                                           </p:stCondLst>
@@ -19421,14 +19985,14 @@
                                 </p:cTn>
                               </p:par>
                               <p:par>
-                                <p:cTn id="33" presetID="19" presetClass="emph" presetSubtype="0" fill="hold" nodeType="withEffect">
+                                <p:cTn id="59" presetID="19" presetClass="emph" presetSubtype="0" fill="hold" nodeType="withEffect">
                                   <p:stCondLst>
                                     <p:cond delay="1200"/>
                                   </p:stCondLst>
                                   <p:childTnLst>
                                     <p:animClr clrSpc="rgb" dir="cw">
                                       <p:cBhvr override="childStyle">
-                                        <p:cTn id="34" dur="500" fill="hold"/>
+                                        <p:cTn id="60" dur="500" fill="hold"/>
                                         <p:tgtEl>
                                           <p:spTgt spid="15">
                                             <p:txEl>
@@ -19446,7 +20010,7 @@
                                     </p:animClr>
                                     <p:animClr clrSpc="rgb" dir="cw">
                                       <p:cBhvr>
-                                        <p:cTn id="35" dur="500" fill="hold"/>
+                                        <p:cTn id="61" dur="500" fill="hold"/>
                                         <p:tgtEl>
                                           <p:spTgt spid="15">
                                             <p:txEl>
@@ -19464,7 +20028,7 @@
                                     </p:animClr>
                                     <p:set>
                                       <p:cBhvr>
-                                        <p:cTn id="36" dur="500" fill="hold"/>
+                                        <p:cTn id="62" dur="500" fill="hold"/>
                                         <p:tgtEl>
                                           <p:spTgt spid="15">
                                             <p:txEl>
@@ -19482,7 +20046,7 @@
                                     </p:set>
                                     <p:set>
                                       <p:cBhvr>
-                                        <p:cTn id="37" dur="500" fill="hold"/>
+                                        <p:cTn id="63" dur="500" fill="hold"/>
                                         <p:tgtEl>
                                           <p:spTgt spid="15">
                                             <p:txEl>
@@ -19496,103 +20060,6 @@
                                       </p:cBhvr>
                                       <p:to>
                                         <p:strVal val="true"/>
-                                      </p:to>
-                                    </p:set>
-                                  </p:childTnLst>
-                                </p:cTn>
-                              </p:par>
-                              <p:par>
-                                <p:cTn id="38" presetID="1" presetClass="entr" presetSubtype="0" fill="hold" grpId="0" nodeType="withEffect">
-                                  <p:stCondLst>
-                                    <p:cond delay="1800"/>
-                                  </p:stCondLst>
-                                  <p:childTnLst>
-                                    <p:set>
-                                      <p:cBhvr>
-                                        <p:cTn id="39" dur="1" fill="hold">
-                                          <p:stCondLst>
-                                            <p:cond delay="0"/>
-                                          </p:stCondLst>
-                                        </p:cTn>
-                                        <p:tgtEl>
-                                          <p:spTgt spid="6"/>
-                                        </p:tgtEl>
-                                        <p:attrNameLst>
-                                          <p:attrName>style.visibility</p:attrName>
-                                        </p:attrNameLst>
-                                      </p:cBhvr>
-                                      <p:to>
-                                        <p:strVal val="visible"/>
-                                      </p:to>
-                                    </p:set>
-                                  </p:childTnLst>
-                                </p:cTn>
-                              </p:par>
-                              <p:par>
-                                <p:cTn id="40" presetID="10" presetClass="exit" presetSubtype="0" fill="hold" grpId="0" nodeType="withEffect">
-                                  <p:stCondLst>
-                                    <p:cond delay="1800"/>
-                                  </p:stCondLst>
-                                  <p:childTnLst>
-                                    <p:animEffect transition="out" filter="fade">
-                                      <p:cBhvr>
-                                        <p:cTn id="41" dur="500"/>
-                                        <p:tgtEl>
-                                          <p:spTgt spid="13"/>
-                                        </p:tgtEl>
-                                      </p:cBhvr>
-                                    </p:animEffect>
-                                    <p:set>
-                                      <p:cBhvr>
-                                        <p:cTn id="42" dur="1" fill="hold">
-                                          <p:stCondLst>
-                                            <p:cond delay="499"/>
-                                          </p:stCondLst>
-                                        </p:cTn>
-                                        <p:tgtEl>
-                                          <p:spTgt spid="13"/>
-                                        </p:tgtEl>
-                                        <p:attrNameLst>
-                                          <p:attrName>style.visibility</p:attrName>
-                                        </p:attrNameLst>
-                                      </p:cBhvr>
-                                      <p:to>
-                                        <p:strVal val="hidden"/>
-                                      </p:to>
-                                    </p:set>
-                                  </p:childTnLst>
-                                </p:cTn>
-                              </p:par>
-                              <p:par>
-                                <p:cTn id="43" presetID="10" presetClass="exit" presetSubtype="0" fill="hold" nodeType="withEffect">
-                                  <p:stCondLst>
-                                    <p:cond delay="1800"/>
-                                  </p:stCondLst>
-                                  <p:childTnLst>
-                                    <p:animEffect transition="out" filter="fade">
-                                      <p:cBhvr>
-                                        <p:cTn id="44" dur="500"/>
-                                        <p:tgtEl>
-                                          <p:spTgt spid="3"/>
-                                        </p:tgtEl>
-                                      </p:cBhvr>
-                                    </p:animEffect>
-                                    <p:set>
-                                      <p:cBhvr>
-                                        <p:cTn id="45" dur="1" fill="hold">
-                                          <p:stCondLst>
-                                            <p:cond delay="499"/>
-                                          </p:stCondLst>
-                                        </p:cTn>
-                                        <p:tgtEl>
-                                          <p:spTgt spid="3"/>
-                                        </p:tgtEl>
-                                        <p:attrNameLst>
-                                          <p:attrName>style.visibility</p:attrName>
-                                        </p:attrNameLst>
-                                      </p:cBhvr>
-                                      <p:to>
-                                        <p:strVal val="hidden"/>
                                       </p:to>
                                     </p:set>
                                   </p:childTnLst>
@@ -19627,7 +20094,9 @@
     </p:tnLst>
     <p:bldLst>
       <p:bldP spid="6" grpId="0" animBg="1"/>
+      <p:bldP spid="6" grpId="1" animBg="1"/>
       <p:bldP spid="13" grpId="0" animBg="1"/>
+      <p:bldP spid="14" grpId="0" animBg="1"/>
     </p:bldLst>
   </p:timing>
 </p:sld>
@@ -19670,7 +20139,7 @@
         </p:nvSpPr>
         <p:spPr>
           <a:xfrm>
-            <a:off x="331872" y="2282620"/>
+            <a:off x="331872" y="2268332"/>
             <a:ext cx="2887578" cy="714377"/>
           </a:xfrm>
           <a:prstGeom prst="roundRect">
@@ -19805,84 +20274,6 @@
   <p:clrMapOvr>
     <a:masterClrMapping/>
   </p:clrMapOvr>
-  <p:timing>
-    <p:tnLst>
-      <p:par>
-        <p:cTn id="1" dur="indefinite" restart="never" nodeType="tmRoot">
-          <p:childTnLst>
-            <p:seq concurrent="1" nextAc="seek">
-              <p:cTn id="2" dur="indefinite" nodeType="mainSeq">
-                <p:childTnLst>
-                  <p:par>
-                    <p:cTn id="3" fill="hold">
-                      <p:stCondLst>
-                        <p:cond delay="indefinite"/>
-                      </p:stCondLst>
-                      <p:childTnLst>
-                        <p:par>
-                          <p:cTn id="4" fill="hold">
-                            <p:stCondLst>
-                              <p:cond delay="0"/>
-                            </p:stCondLst>
-                            <p:childTnLst>
-                              <p:par>
-                                <p:cTn id="5" presetID="1" presetClass="entr" presetSubtype="0" fill="hold" grpId="0" nodeType="clickEffect">
-                                  <p:stCondLst>
-                                    <p:cond delay="0"/>
-                                  </p:stCondLst>
-                                  <p:childTnLst>
-                                    <p:set>
-                                      <p:cBhvr>
-                                        <p:cTn id="6" dur="1" fill="hold">
-                                          <p:stCondLst>
-                                            <p:cond delay="0"/>
-                                          </p:stCondLst>
-                                        </p:cTn>
-                                        <p:tgtEl>
-                                          <p:spTgt spid="8"/>
-                                        </p:tgtEl>
-                                        <p:attrNameLst>
-                                          <p:attrName>style.visibility</p:attrName>
-                                        </p:attrNameLst>
-                                      </p:cBhvr>
-                                      <p:to>
-                                        <p:strVal val="visible"/>
-                                      </p:to>
-                                    </p:set>
-                                  </p:childTnLst>
-                                </p:cTn>
-                              </p:par>
-                            </p:childTnLst>
-                          </p:cTn>
-                        </p:par>
-                      </p:childTnLst>
-                    </p:cTn>
-                  </p:par>
-                </p:childTnLst>
-              </p:cTn>
-              <p:prevCondLst>
-                <p:cond evt="onPrev" delay="0">
-                  <p:tgtEl>
-                    <p:sldTgt/>
-                  </p:tgtEl>
-                </p:cond>
-              </p:prevCondLst>
-              <p:nextCondLst>
-                <p:cond evt="onNext" delay="0">
-                  <p:tgtEl>
-                    <p:sldTgt/>
-                  </p:tgtEl>
-                </p:cond>
-              </p:nextCondLst>
-            </p:seq>
-          </p:childTnLst>
-        </p:cTn>
-      </p:par>
-    </p:tnLst>
-    <p:bldLst>
-      <p:bldP spid="8" grpId="0" animBg="1"/>
-    </p:bldLst>
-  </p:timing>
 </p:sld>
 </file>
 
@@ -19909,89 +20300,6 @@
           <a:chExt cx="0" cy="0"/>
         </a:xfrm>
       </p:grpSpPr>
-      <p:sp>
-        <p:nvSpPr>
-          <p:cNvPr id="6" name="TextBox 5">
-            <a:extLst>
-              <a:ext uri="{FF2B5EF4-FFF2-40B4-BE49-F238E27FC236}">
-                <a16:creationId xmlns:a16="http://schemas.microsoft.com/office/drawing/2014/main" id="{3781749F-2DE4-6052-FCC1-9E1C1554116A}"/>
-              </a:ext>
-            </a:extLst>
-          </p:cNvPr>
-          <p:cNvSpPr txBox="1"/>
-          <p:nvPr/>
-        </p:nvSpPr>
-        <p:spPr>
-          <a:xfrm>
-            <a:off x="440111" y="376344"/>
-            <a:ext cx="1588897" cy="2550378"/>
-          </a:xfrm>
-          <a:prstGeom prst="rect">
-            <a:avLst/>
-          </a:prstGeom>
-          <a:noFill/>
-        </p:spPr>
-        <p:txBody>
-          <a:bodyPr wrap="none" rtlCol="0">
-            <a:spAutoFit/>
-          </a:bodyPr>
-          <a:lstStyle/>
-          <a:p>
-            <a:pPr>
-              <a:lnSpc>
-                <a:spcPct val="200000"/>
-              </a:lnSpc>
-            </a:pPr>
-            <a:r>
-              <a:rPr lang="en-CA" sz="2800" dirty="0">
-                <a:solidFill>
-                  <a:schemeClr val="tx1">
-                    <a:lumMod val="25000"/>
-                    <a:lumOff val="75000"/>
-                  </a:schemeClr>
-                </a:solidFill>
-                <a:latin typeface="Kumbh Sans" pitchFamily="2" charset="0"/>
-                <a:cs typeface="Kumbh Sans" pitchFamily="2" charset="0"/>
-              </a:rPr>
-              <a:t>Adestria</a:t>
-            </a:r>
-          </a:p>
-          <a:p>
-            <a:pPr>
-              <a:lnSpc>
-                <a:spcPct val="200000"/>
-              </a:lnSpc>
-            </a:pPr>
-            <a:r>
-              <a:rPr lang="en-CA" sz="2800" dirty="0">
-                <a:solidFill>
-                  <a:schemeClr val="tx1">
-                    <a:lumMod val="25000"/>
-                    <a:lumOff val="75000"/>
-                  </a:schemeClr>
-                </a:solidFill>
-                <a:latin typeface="Kumbh Sans" pitchFamily="2" charset="0"/>
-                <a:cs typeface="Kumbh Sans" pitchFamily="2" charset="0"/>
-              </a:rPr>
-              <a:t>Project</a:t>
-            </a:r>
-          </a:p>
-          <a:p>
-            <a:pPr>
-              <a:lnSpc>
-                <a:spcPct val="200000"/>
-              </a:lnSpc>
-            </a:pPr>
-            <a:r>
-              <a:rPr lang="en-CA" sz="2800" dirty="0">
-                <a:latin typeface="Kumbh Sans" pitchFamily="2" charset="0"/>
-                <a:cs typeface="Kumbh Sans" pitchFamily="2" charset="0"/>
-              </a:rPr>
-              <a:t>Q &amp; A</a:t>
-            </a:r>
-          </a:p>
-        </p:txBody>
-      </p:sp>
     </p:spTree>
     <p:extLst>
       <p:ext uri="{BB962C8B-B14F-4D97-AF65-F5344CB8AC3E}">
@@ -20002,42 +20310,18 @@
   <p:clrMapOvr>
     <a:masterClrMapping/>
   </p:clrMapOvr>
-</p:sld>
-</file>
-
-<file path=ppt/slides/slide17.xml><?xml version="1.0" encoding="utf-8"?>
-<p:sld xmlns:a="http://schemas.openxmlformats.org/drawingml/2006/main" xmlns:r="http://schemas.openxmlformats.org/officeDocument/2006/relationships" xmlns:p="http://schemas.openxmlformats.org/presentationml/2006/main">
-  <p:cSld>
-    <p:spTree>
-      <p:nvGrpSpPr>
-        <p:cNvPr id="1" name="">
-          <a:extLst>
-            <a:ext uri="{FF2B5EF4-FFF2-40B4-BE49-F238E27FC236}">
-              <a16:creationId xmlns:a16="http://schemas.microsoft.com/office/drawing/2014/main" id="{D906F22D-BE40-925B-D0B4-154AD0607E50}"/>
-            </a:ext>
-          </a:extLst>
-        </p:cNvPr>
-        <p:cNvGrpSpPr/>
-        <p:nvPr/>
-      </p:nvGrpSpPr>
-      <p:grpSpPr>
-        <a:xfrm>
-          <a:off x="0" y="0"/>
-          <a:ext cx="0" cy="0"/>
-          <a:chOff x="0" y="0"/>
-          <a:chExt cx="0" cy="0"/>
-        </a:xfrm>
-      </p:grpSpPr>
-    </p:spTree>
-    <p:extLst>
-      <p:ext uri="{BB962C8B-B14F-4D97-AF65-F5344CB8AC3E}">
-        <p14:creationId xmlns:p14="http://schemas.microsoft.com/office/powerpoint/2010/main" val="1557603729"/>
-      </p:ext>
-    </p:extLst>
-  </p:cSld>
-  <p:clrMapOvr>
-    <a:masterClrMapping/>
-  </p:clrMapOvr>
+  <mc:AlternateContent xmlns:mc="http://schemas.openxmlformats.org/markup-compatibility/2006">
+    <mc:Choice xmlns:p14="http://schemas.microsoft.com/office/powerpoint/2010/main" Requires="p14">
+      <p:transition spd="med" p14:dur="700">
+        <p:fade/>
+      </p:transition>
+    </mc:Choice>
+    <mc:Fallback>
+      <p:transition spd="med">
+        <p:fade/>
+      </p:transition>
+    </mc:Fallback>
+  </mc:AlternateContent>
 </p:sld>
 </file>
 
@@ -25025,153 +25309,6 @@
                       </p:childTnLst>
                     </p:cTn>
                   </p:par>
-                  <p:par>
-                    <p:cTn id="54" fill="hold">
-                      <p:stCondLst>
-                        <p:cond delay="indefinite"/>
-                      </p:stCondLst>
-                      <p:childTnLst>
-                        <p:par>
-                          <p:cTn id="55" fill="hold">
-                            <p:stCondLst>
-                              <p:cond delay="0"/>
-                            </p:stCondLst>
-                            <p:childTnLst>
-                              <p:par>
-                                <p:cTn id="56" presetID="10" presetClass="exit" presetSubtype="0" fill="hold" grpId="0" nodeType="clickEffect">
-                                  <p:stCondLst>
-                                    <p:cond delay="0"/>
-                                  </p:stCondLst>
-                                  <p:childTnLst>
-                                    <p:animEffect transition="out" filter="fade">
-                                      <p:cBhvr>
-                                        <p:cTn id="57" dur="500"/>
-                                        <p:tgtEl>
-                                          <p:spTgt spid="2">
-                                            <p:txEl>
-                                              <p:pRg st="0" end="0"/>
-                                            </p:txEl>
-                                          </p:spTgt>
-                                        </p:tgtEl>
-                                      </p:cBhvr>
-                                    </p:animEffect>
-                                    <p:set>
-                                      <p:cBhvr>
-                                        <p:cTn id="58" dur="1" fill="hold">
-                                          <p:stCondLst>
-                                            <p:cond delay="499"/>
-                                          </p:stCondLst>
-                                        </p:cTn>
-                                        <p:tgtEl>
-                                          <p:spTgt spid="2">
-                                            <p:txEl>
-                                              <p:pRg st="0" end="0"/>
-                                            </p:txEl>
-                                          </p:spTgt>
-                                        </p:tgtEl>
-                                        <p:attrNameLst>
-                                          <p:attrName>style.visibility</p:attrName>
-                                        </p:attrNameLst>
-                                      </p:cBhvr>
-                                      <p:to>
-                                        <p:strVal val="hidden"/>
-                                      </p:to>
-                                    </p:set>
-                                  </p:childTnLst>
-                                </p:cTn>
-                              </p:par>
-                              <p:par>
-                                <p:cTn id="59" presetID="10" presetClass="exit" presetSubtype="0" fill="hold" grpId="0" nodeType="withEffect">
-                                  <p:stCondLst>
-                                    <p:cond delay="0"/>
-                                  </p:stCondLst>
-                                  <p:childTnLst>
-                                    <p:animEffect transition="out" filter="fade">
-                                      <p:cBhvr>
-                                        <p:cTn id="60" dur="500"/>
-                                        <p:tgtEl>
-                                          <p:spTgt spid="2">
-                                            <p:txEl>
-                                              <p:pRg st="1" end="1"/>
-                                            </p:txEl>
-                                          </p:spTgt>
-                                        </p:tgtEl>
-                                      </p:cBhvr>
-                                    </p:animEffect>
-                                    <p:set>
-                                      <p:cBhvr>
-                                        <p:cTn id="61" dur="1" fill="hold">
-                                          <p:stCondLst>
-                                            <p:cond delay="499"/>
-                                          </p:stCondLst>
-                                        </p:cTn>
-                                        <p:tgtEl>
-                                          <p:spTgt spid="2">
-                                            <p:txEl>
-                                              <p:pRg st="1" end="1"/>
-                                            </p:txEl>
-                                          </p:spTgt>
-                                        </p:tgtEl>
-                                        <p:attrNameLst>
-                                          <p:attrName>style.visibility</p:attrName>
-                                        </p:attrNameLst>
-                                      </p:cBhvr>
-                                      <p:to>
-                                        <p:strVal val="hidden"/>
-                                      </p:to>
-                                    </p:set>
-                                  </p:childTnLst>
-                                </p:cTn>
-                              </p:par>
-                              <p:par>
-                                <p:cTn id="62" presetID="10" presetClass="exit" presetSubtype="0" fill="hold" grpId="0" nodeType="withEffect">
-                                  <p:stCondLst>
-                                    <p:cond delay="0"/>
-                                  </p:stCondLst>
-                                  <p:childTnLst>
-                                    <p:animEffect transition="out" filter="fade">
-                                      <p:cBhvr>
-                                        <p:cTn id="63" dur="500"/>
-                                        <p:tgtEl>
-                                          <p:spTgt spid="2">
-                                            <p:txEl>
-                                              <p:pRg st="2" end="2"/>
-                                            </p:txEl>
-                                          </p:spTgt>
-                                        </p:tgtEl>
-                                      </p:cBhvr>
-                                    </p:animEffect>
-                                    <p:set>
-                                      <p:cBhvr>
-                                        <p:cTn id="64" dur="1" fill="hold">
-                                          <p:stCondLst>
-                                            <p:cond delay="499"/>
-                                          </p:stCondLst>
-                                        </p:cTn>
-                                        <p:tgtEl>
-                                          <p:spTgt spid="2">
-                                            <p:txEl>
-                                              <p:pRg st="2" end="2"/>
-                                            </p:txEl>
-                                          </p:spTgt>
-                                        </p:tgtEl>
-                                        <p:attrNameLst>
-                                          <p:attrName>style.visibility</p:attrName>
-                                        </p:attrNameLst>
-                                      </p:cBhvr>
-                                      <p:to>
-                                        <p:strVal val="hidden"/>
-                                      </p:to>
-                                    </p:set>
-                                  </p:childTnLst>
-                                </p:cTn>
-                              </p:par>
-                            </p:childTnLst>
-                          </p:cTn>
-                        </p:par>
-                      </p:childTnLst>
-                    </p:cTn>
-                  </p:par>
                 </p:childTnLst>
               </p:cTn>
               <p:prevCondLst>
@@ -25196,7 +25333,6 @@
     <p:bldLst>
       <p:bldP spid="11" grpId="0" animBg="1"/>
       <p:bldP spid="3" grpId="0"/>
-      <p:bldP spid="2" grpId="0" build="allAtOnce"/>
     </p:bldLst>
   </p:timing>
 </p:sld>
@@ -25844,6 +25980,18 @@
   <p:clrMapOvr>
     <a:masterClrMapping/>
   </p:clrMapOvr>
+  <mc:AlternateContent xmlns:mc="http://schemas.openxmlformats.org/markup-compatibility/2006">
+    <mc:Choice xmlns:p14="http://schemas.microsoft.com/office/powerpoint/2010/main" Requires="p14">
+      <p:transition spd="med" p14:dur="700">
+        <p:fade/>
+      </p:transition>
+    </mc:Choice>
+    <mc:Fallback>
+      <p:transition spd="med">
+        <p:fade/>
+      </p:transition>
+    </mc:Fallback>
+  </mc:AlternateContent>
   <p:timing>
     <p:tnLst>
       <p:par>
@@ -26744,6 +26892,18 @@
   <p:clrMapOvr>
     <a:masterClrMapping/>
   </p:clrMapOvr>
+  <mc:AlternateContent xmlns:mc="http://schemas.openxmlformats.org/markup-compatibility/2006">
+    <mc:Choice xmlns:p14="http://schemas.microsoft.com/office/powerpoint/2010/main" Requires="p14">
+      <p:transition spd="med" p14:dur="700">
+        <p:fade/>
+      </p:transition>
+    </mc:Choice>
+    <mc:Fallback>
+      <p:transition spd="med">
+        <p:fade/>
+      </p:transition>
+    </mc:Fallback>
+  </mc:AlternateContent>
   <p:timing>
     <p:tnLst>
       <p:par>
@@ -27597,6 +27757,18 @@
   <p:clrMapOvr>
     <a:masterClrMapping/>
   </p:clrMapOvr>
+  <mc:AlternateContent xmlns:mc="http://schemas.openxmlformats.org/markup-compatibility/2006">
+    <mc:Choice xmlns:p14="http://schemas.microsoft.com/office/powerpoint/2010/main" Requires="p14">
+      <p:transition spd="med" p14:dur="700">
+        <p:fade/>
+      </p:transition>
+    </mc:Choice>
+    <mc:Fallback>
+      <p:transition spd="med">
+        <p:fade/>
+      </p:transition>
+    </mc:Fallback>
+  </mc:AlternateContent>
   <p:timing>
     <p:tnLst>
       <p:par>
@@ -28656,6 +28828,18 @@
   <p:clrMapOvr>
     <a:masterClrMapping/>
   </p:clrMapOvr>
+  <mc:AlternateContent xmlns:mc="http://schemas.openxmlformats.org/markup-compatibility/2006">
+    <mc:Choice xmlns:p14="http://schemas.microsoft.com/office/powerpoint/2010/main" Requires="p14">
+      <p:transition spd="med" p14:dur="700">
+        <p:fade/>
+      </p:transition>
+    </mc:Choice>
+    <mc:Fallback>
+      <p:transition spd="med">
+        <p:fade/>
+      </p:transition>
+    </mc:Fallback>
+  </mc:AlternateContent>
   <p:timing>
     <p:tnLst>
       <p:par>

</xml_diff>

<commit_message>
Update data model again
</commit_message>
<xml_diff>
--- a/Deliverables/Presentation1.pptx
+++ b/Deliverables/Presentation1.pptx
@@ -145,7 +145,7 @@
 <file path=ppt/revisionInfo.xml><?xml version="1.0" encoding="utf-8"?>
 <p1510:revInfo xmlns:a="http://schemas.openxmlformats.org/drawingml/2006/main" xmlns:r="http://schemas.openxmlformats.org/officeDocument/2006/relationships" xmlns:p1510="http://schemas.microsoft.com/office/powerpoint/2015/10/main">
   <p1510:revLst>
-    <p1510:client id="{EADFFEA0-CC63-45EF-97E4-5A80CDB68182}" v="12" dt="2026-09-21T10:37:03.825"/>
+    <p1510:client id="{EADFFEA0-CC63-45EF-97E4-5A80CDB68182}" v="13" dt="2026-09-21T10:38:25.208"/>
   </p1510:revLst>
 </p1510:revInfo>
 </file>
@@ -155,7 +155,7 @@
   <pc:docChgLst>
     <pc:chgData name="Steve Mutrux" userId="4fa98d0c-dc66-4728-b09b-a88e22e95094" providerId="ADAL" clId="{421BD283-33D8-4C6C-821F-71755E863FA2}"/>
     <pc:docChg chg="undo custSel addSld delSld modSld sldOrd">
-      <pc:chgData name="Steve Mutrux" userId="4fa98d0c-dc66-4728-b09b-a88e22e95094" providerId="ADAL" clId="{421BD283-33D8-4C6C-821F-71755E863FA2}" dt="2026-09-21T10:37:25.030" v="5837" actId="14100"/>
+      <pc:chgData name="Steve Mutrux" userId="4fa98d0c-dc66-4728-b09b-a88e22e95094" providerId="ADAL" clId="{421BD283-33D8-4C6C-821F-71755E863FA2}" dt="2026-09-21T10:38:25.208" v="5838" actId="14826"/>
       <pc:docMkLst>
         <pc:docMk/>
       </pc:docMkLst>
@@ -492,7 +492,7 @@
         </pc:grpChg>
       </pc:sldChg>
       <pc:sldChg chg="addSp delSp modSp add mod modTransition addAnim delAnim modAnim modNotesTx">
-        <pc:chgData name="Steve Mutrux" userId="4fa98d0c-dc66-4728-b09b-a88e22e95094" providerId="ADAL" clId="{421BD283-33D8-4C6C-821F-71755E863FA2}" dt="2026-09-21T02:38:56.379" v="5815" actId="14826"/>
+        <pc:chgData name="Steve Mutrux" userId="4fa98d0c-dc66-4728-b09b-a88e22e95094" providerId="ADAL" clId="{421BD283-33D8-4C6C-821F-71755E863FA2}" dt="2026-09-21T10:38:25.208" v="5838" actId="14826"/>
         <pc:sldMkLst>
           <pc:docMk/>
           <pc:sldMk cId="4190029259" sldId="261"/>
@@ -658,7 +658,7 @@
           </ac:grpSpMkLst>
         </pc:grpChg>
         <pc:picChg chg="add mod">
-          <ac:chgData name="Steve Mutrux" userId="4fa98d0c-dc66-4728-b09b-a88e22e95094" providerId="ADAL" clId="{421BD283-33D8-4C6C-821F-71755E863FA2}" dt="2026-09-21T02:38:56.379" v="5815" actId="14826"/>
+          <ac:chgData name="Steve Mutrux" userId="4fa98d0c-dc66-4728-b09b-a88e22e95094" providerId="ADAL" clId="{421BD283-33D8-4C6C-821F-71755E863FA2}" dt="2026-09-21T10:38:25.208" v="5838" actId="14826"/>
           <ac:picMkLst>
             <pc:docMk/>
             <pc:sldMk cId="4190029259" sldId="261"/>
@@ -14510,8 +14510,8 @@
         </p:blipFill>
         <p:spPr>
           <a:xfrm>
-            <a:off x="3402800" y="1771869"/>
-            <a:ext cx="7967662" cy="3206424"/>
+            <a:off x="3514723" y="1771869"/>
+            <a:ext cx="7743816" cy="3206424"/>
           </a:xfrm>
           <a:prstGeom prst="rect">
             <a:avLst/>

</xml_diff>